<commit_message>
Presentation: remediation count 18 -> 19 to match the log
</commit_message>
<xml_diff>
--- a/presentation/ScholarPlan_Unit11_Presentation.pptx
+++ b/presentation/ScholarPlan_Unit11_Presentation.pptx
@@ -116,12 +116,12 @@
   <p:extLst>
     <p:ext uri="{521415D9-36F7-43E2-AB2F-B90AF26B5E84}">
       <p14:sectionLst xmlns:p14="http://schemas.microsoft.com/office/powerpoint/2010/main">
-        <p14:section name="Introduction" id="{23afefe5-ee01-b8ac-7d34-7224275f3d17}">
+        <p14:section name="Introduction" id="{f17bb284-1b4b-f5c7-6cfb-279d3a848286}">
           <p14:sldIdLst>
             <p14:sldId id="256"/>
           </p14:sldIdLst>
         </p14:section>
-        <p14:section name="System" id="{c6059fa8-ae3f-af61-b5e0-c6da22403621}">
+        <p14:section name="System" id="{5b495cd2-5d51-1fe7-1f08-734b75b074f2}">
           <p14:sldIdLst>
             <p14:sldId id="257"/>
             <p14:sldId id="258"/>
@@ -129,18 +129,18 @@
             <p14:sldId id="260"/>
           </p14:sldIdLst>
         </p14:section>
-        <p14:section name="Demonstration" id="{79505043-4827-08d5-bc66-71aa3002c605}">
+        <p14:section name="Demonstration" id="{951abbce-ef28-cc9d-4ed3-cbd08a7b3c20}">
           <p14:sldIdLst>
             <p14:sldId id="261"/>
           </p14:sldIdLst>
         </p14:section>
-        <p14:section name="Evidence" id="{ecc9b721-f7df-51cf-9937-99a9235ba6fe}">
+        <p14:section name="Evidence" id="{5d921f20-bd6f-9b7e-6284-bc3e73eed2c1}">
           <p14:sldIdLst>
             <p14:sldId id="262"/>
             <p14:sldId id="263"/>
           </p14:sldIdLst>
         </p14:section>
-        <p14:section name="Reflection" id="{b2005f5b-26fe-db35-0e09-30d4db9810e3}">
+        <p14:section name="Reflection" id="{c968a9b4-b5e6-b656-6303-8aff606b863e}">
           <p14:sldIdLst>
             <p14:sldId id="264"/>
             <p14:sldId id="265"/>
@@ -1720,7 +1720,7 @@
               <a:rPr lang="en-US" dirty="0"/>
               <a:t>Testing followed the Unit 6 plan of testing by agent type. Deterministic components have conventional unit tests: 82 of them, covering blackboard atomicity and permissions, API parsers run against recorded real responses, rate limiting and retries, the thresholds, Planner rules and citation formatting. Twelve functional tests run the whole system end to end, offline, and each one forces a specific behaviour: Critic rejection leading to re-planning, the three-re-plan cap, budget exhaustion, an injected hallucination being filtered, and an API failing mid-run. Four live smoke tests detect drift in the external services. Overall: 94 passing tests and 93 percent line coverage.
 The scripted mock LLM is what makes this possible: a real model will not reject claims on demand, but a scripted one can, deterministically.
-Every defect is recorded in a remediation log, eighteen in total, each with its root cause, fix and verifying test. Three stand out. The Critic model chosen in Unit 6 was withdrawn by the provider, so I added an automatic model-substitution mechanism and a regression test. OpenAlex returned "too many requests" errors in the first live run, so the client now honours the server's retry-after header. And most interesting: in a live run, the Planner misdiagnosed a model formatting error as a bad query and rewrote a perfectly good query, because the feedback message did not state the cause. The lesson is that Reflexion-style self-correction is only as good as its feedback signal, so feedback now carries the diagnosis.
+Every defect is recorded in a remediation log, nineteen in total, each with its root cause, fix and verifying test. Three stand out. The Critic model chosen in Unit 6 was withdrawn by the provider, so I added an automatic model-substitution mechanism and a regression test. OpenAlex returned "too many requests" errors in the first live run, so the client now honours the server's retry-after header. And most interesting: in a live run, the Planner misdiagnosed a model formatting error as a bad query and rewrote a perfectly good query, because the feedback message did not state the cause. The lesson is that Reflexion-style self-correction is only as good as its feedback signal, so feedback now carries the diagnosis.
 Progress is visible in the Git history: from the Unit 6 design, through seven short sprints, each ending in a tested increment.</a:t>
             </a:r>
             <a:endParaRPr lang="en-US" dirty="0"/>
@@ -13515,7 +13515,7 @@
                 <a:ea typeface="Cambria" pitchFamily="34" charset="-122"/>
                 <a:cs typeface="Cambria" pitchFamily="34" charset="-120"/>
               </a:rPr>
-              <a:t>18</a:t>
+              <a:t>19</a:t>
             </a:r>
             <a:endParaRPr lang="en-US" sz="3000" dirty="0"/>
           </a:p>

</xml_diff>

<commit_message>
Slide 6 as screenshot walkthrough of live runs; citation rendering fix (R20); verification fixes
- Slide 6: four cropped dashboard panels (plan, Critic rejection, re-planning, report) with evidence strip
- Report citations: tolerant [C n] pattern, adjacent markers merged into one Harvard parenthetical
- Corrected facts: arXiv 8/10 hits, seven hallucination types, eight sprints, 96 tests / 92% coverage / 20 remediations
- Evidence: first live run published, run logs tracked, stray files removed, R20 before/after report
- Slides: UML composition/generalisation symbols, slide 3 connectors, slide 5 narration positions
</commit_message>
<xml_diff>
--- a/presentation/ScholarPlan_Unit11_Presentation.pptx
+++ b/presentation/ScholarPlan_Unit11_Presentation.pptx
@@ -116,12 +116,12 @@
   <p:extLst>
     <p:ext uri="{521415D9-36F7-43E2-AB2F-B90AF26B5E84}">
       <p14:sectionLst xmlns:p14="http://schemas.microsoft.com/office/powerpoint/2010/main">
-        <p14:section name="Introduction" id="{f17bb284-1b4b-f5c7-6cfb-279d3a848286}">
+        <p14:section name="Introduction" id="{66669020-028e-a083-65de-6c5c3fd54512}">
           <p14:sldIdLst>
             <p14:sldId id="256"/>
           </p14:sldIdLst>
         </p14:section>
-        <p14:section name="System" id="{5b495cd2-5d51-1fe7-1f08-734b75b074f2}">
+        <p14:section name="System" id="{33a0cdd5-1c03-97b9-b8fa-7b33f671a03c}">
           <p14:sldIdLst>
             <p14:sldId id="257"/>
             <p14:sldId id="258"/>
@@ -129,18 +129,18 @@
             <p14:sldId id="260"/>
           </p14:sldIdLst>
         </p14:section>
-        <p14:section name="Demonstration" id="{951abbce-ef28-cc9d-4ed3-cbd08a7b3c20}">
+        <p14:section name="Demonstration" id="{bb3d5ab5-9aee-235b-1e3e-7db59d536c64}">
           <p14:sldIdLst>
             <p14:sldId id="261"/>
           </p14:sldIdLst>
         </p14:section>
-        <p14:section name="Evidence" id="{5d921f20-bd6f-9b7e-6284-bc3e73eed2c1}">
+        <p14:section name="Evidence" id="{e0ea083e-ae68-1e3a-d6ae-8a8f3507acbb}">
           <p14:sldIdLst>
             <p14:sldId id="262"/>
             <p14:sldId id="263"/>
           </p14:sldIdLst>
         </p14:section>
-        <p14:section name="Reflection" id="{c968a9b4-b5e6-b656-6303-8aff606b863e}">
+        <p14:section name="Reflection" id="{c6df5d74-0534-f532-f927-e91ac627c98a}">
           <p14:sldIdLst>
             <p14:sldId id="264"/>
             <p14:sldId id="265"/>
@@ -980,7 +980,7 @@
             <a:r>
               <a:rPr lang="en-US" dirty="0"/>
               <a:t>Hello, my name is Adil Aljasmi. This presentation covers the second deliverable of the Intelligent Agents module: the implementation of ScholarPlan.
-In Unit 6, our group designed ScholarPlan, an LLM-powered planning agent for academic research and information gathering. In Unit 11 I built that design, individually, as a working multi-agent system. Over the next twenty minutes I will show how the implementation meets the design, demonstrate it running live, explain how it was tested and evaluated against measurable targets, and reflect critically on what worked, what changed, and why.</a:t>
+In Unit 6, our group designed ScholarPlan, an LLM-powered planning agent for academic research and information gathering. In Unit 11 I built that design, individually, as a working multi-agent system. Over the next twenty minutes I will show how the implementation meets the design, walk through it running on a real research question, explain how it was tested and evaluated against measurable targets, and reflect critically on what worked, what changed, and why.</a:t>
             </a:r>
             <a:endParaRPr lang="en-US" dirty="0"/>
           </a:p>
@@ -1069,7 +1069,7 @@
             <a:r>
               <a:rPr lang="en-US" dirty="0"/>
               <a:t>To conclude: ScholarPlan implements the Unit 6 design as a working, tested multi-agent system. A deliberative ReAct planner and reactive specialists coordinate through a blackboard, an independent Critic filters hallucinations, and the results are stored offline with full provenance. It meets the measurable targets the design was criticised for lacking, and every change from the plan is documented and justified.
-The broader lesson is the LLM-Modulo one: let the language model supply judgement, and let code guarantee validity and termination.
+The broader lesson is the LLM-Modulo one: let the language model supply judgement and let code guarantee validity and termination.
 The code, tests, evidence and README with full references are in my GitHub repository. Thank you for listening.</a:t>
             </a:r>
             <a:endParaRPr lang="en-US" dirty="0"/>
@@ -1161,7 +1161,7 @@
               <a:t>The problem ScholarPlan addresses is simple to state. Searching the literature is repetitive, but handing the task to a single large language model is risky: unaided LLMs plan unreliably (Kambhampati et al., 2024) and they fabricate citations and facts (Ji et al., 2023).
 So ScholarPlan splits the work between five cooperating agents. You give it a research goal in plain English. The Planner decomposes it into search subtasks. The Retriever queries three open scholarly APIs: arXiv, OpenAlex and Crossref. The Processor removes duplicates, ranks the results and turns each abstract into short, atomic claims. The Critic, a separate model, checks every claim against the source it came from. Finally, the Archivist stores a cited report, a BibTeX file, a searchable vector index and a full reasoning trace offline.
 This maps directly onto the three success criteria in the brief: relevant data is identified and retrieved; it is processed by filtering, summarising and verifying; and it is stored in a usable format.
-The numbers on the right summarise where the project ended up. All five agents are implemented. There are 94 automated tests with 93 percent line coverage. And in live evaluation, three out of three research goals completed within the step budget, averaging under seven reasoning steps and about one minute each.</a:t>
+The numbers on the right summarise where the project ended up. All five agents are implemented. There are 96 automated tests with 92 percent line coverage. And in live evaluation, three out of three research goals completed within the step budget, averaging under seven reasoning steps and about one minute each.</a:t>
             </a:r>
             <a:endParaRPr lang="en-US" dirty="0"/>
           </a:p>
@@ -1435,8 +1435,8 @@
               <a:rPr lang="en-US" dirty="0"/>
               <a:t>The Unit 6 feedback noted that our design had behavioural diagrams, an activity diagram and a sequence diagram, but no static structural view. This class diagram adds that view, and it is drawn from the actual code.
 At the top, the Controller aggregates five Agent objects. Agent is an abstract class with two methods: can-act, a cheap side-effect-free trigger check, and act. The five roles inherit from it. Every agent reaches the blackboard only through a ScopedBlackboard, which enforces that role's permissions.
-On the right is the dependency-inversion principle at work. The three LLM-using agents depend on an LLMClient interface, not on Groq. There are three implementations: the live OpenAI-compatible client, a deterministic mock and a scripted mock used to force failure paths in tests. Switching provider is a configuration change. That is exactly what made the model changes I will discuss later cheap to make.
-At the bottom, the Retriever uses three API clients sharing one polite, cached, rate-limited HTTP component, and all thresholds live in a single frozen Settings object, so the numbers I quote are defined in one place.</a:t>
+At the bottom left is the dependency-inversion principle at work. The three LLM-using agents depend on an LLMClient interface, not on Groq. There are three implementations: the live OpenAI-compatible client, a deterministic mock and a scripted mock used to force failure paths in tests. Switching provider is a configuration change. That is exactly what made the model changes I will discuss later cheap to make.
+At the bottom right, the Retriever uses three API clients sharing one polite, cached, rate-limited HTTP component, and all thresholds live in a single frozen Settings object, so the numbers I quote are defined in one place.</a:t>
             </a:r>
             <a:endParaRPr lang="en-US" dirty="0"/>
           </a:p>
@@ -1524,21 +1524,17 @@
           <a:p>
             <a:r>
               <a:rPr lang="en-US" dirty="0"/>
-              <a:t>[Switch to the browser showing the dashboard, http://localhost:8501. The sidebar should already show the goal. Turn ON "Demo: inject a fabricated claim". Click "Run agents".]
-Let me show the system running. This is the ScholarPlan dashboard, written in Streamlit. The agents run in a background thread while the page reads the same SQLite blackboard every second, so what you see is the blackboard itself.
-I've entered the goal "How do LLM-based critics or verifiers detect hallucinated claims?", and I've switched on a clearly labelled demo option that plants one false claim. Live runs rarely hallucinate on cue, and I want to show the Critic catching one.
-[As the trace fills.]
-First, the Planner's thought: it explains how it will decompose the goal, then creates four subtasks. Notice the agent cards: the highlighted card shows who is acting. Now the Retriever is searching arXiv, OpenAlex and Crossref; the observation shows how many records came from each. The Processor reports how many candidates it had, how many duplicates it removed, and how many it selected.
-[When the Critic verdicts appear, click "Claims &amp; verdicts".]
-Here is the interesting part. The trace shows a line marked DEMO: the injected claim says the method "eliminates hallucination entirely and improves accuracy by 99 percent on every benchmark". The Critic, running on a different model family, rejected it. Its reason says the source reports an AUROC of 0.781 and specific improvements, not the elimination of hallucination. Opening the claim shows the real abstract underneath, so anyone can audit the judgement.
-[Click "Feedback", then "Subtasks".]
-The subtask still passed, because two of its three claims were supported, but the false claim will never reach the report. If too many claims fail, this feedback tab shows the message the Planner reads before re-planning. In an earlier live evaluation run you can see two genuine re-plans recorded here.
-[When the run finishes, click "Report".]
-The run is complete. The report has an answer with Harvard in-text citations, an evidence table where every claim has an identifier, the subtasks with their outcomes, and the reference list. There are download buttons for the BibTeX file and the trace, and I can query the saved vector index semantically. Let me type "how are hallucinations scored" and the index returns the closest verified claims.
-[Switch to VS Code. Open src/scholarplan/agents/planner.py and scroll to `_react_step` and `_validate`.]
-Briefly, in the code: this is the ReAct step. Allowed actions are computed here, by code; the LLM's choice is validated here; and if it fails, the fallback policy is used. Every comment explains why a decision was made, with its source, rather than restating what the line does.
-[Open blackboard.py at `claim_subtask` for a few seconds, then return to the slides.]
-And this is the atomic claim: one immediate transaction, re-checking the status in the update itself.</a:t>
+              <a:t>These four panels are captured from real live runs, using the ScholarPlan dashboard. The dashboard reads the SQLite blackboard every second, so what you see is exactly what the agents recorded. The goal for this run was "How do LLM-based critics or verifiers detect hallucinated claims?". I also switched on a clearly labelled demonstration option that plants one false claim, because live runs rarely hallucinate on cue and I wanted to show the Critic catching one.
+[Panel 1]
+Panel one is the ReAct loop in action. The Planner's first thought explains how it will decompose the goal: detection methods, training signals, evaluation benchmarks and known limitations. Its action creates a four-subtask plan. At the next step it reasons that it needs evidence first, and issues the first of those subtasks, number five on this shared blackboard. From there the specialists take over through the blackboard. The run's saved summary records that the Retriever collected sixty records from the three APIs, the Processor removed ten duplicates and kept the most relevant sources, and all four subtasks were verified in six of the twenty allowed steps.
+[Panel 2]
+Panel two is the key moment. Claim C22, the planted one, says the study "eliminates hallucination entirely and improves accuracy by 99 percent on every benchmark". The Critic, a model from a different family than the one that wrote the claims, rejected it, and its reason is precise: the source reports an AUROC of 0.781 and specific percentage improvements, not the elimination of hallucination. The genuine claims from the same abstract, C20 and C21, were accepted. Sixteen of seventeen claims survived, and the false one never reaches the report.
+[Panel 3]
+Panel three comes from an earlier live evaluation run, where re-planning happened for real. The Processor's model twice failed to return valid output, and each time it wrote feedback to the blackboard. The Planner read that feedback and re-planned twice, and the run still finished with all four subtasks verified, in eight steps. This is also where I found the misdiagnosis problem I will return to under testing.
+[Panel 4]
+Panel four is the stored result: the Archivist's report, shown after a citation-formatting fix I made while preparing these slides, remediation R20. The content is unchanged, and both versions are in the evidence folder. The report answers the goal with Harvard in-text citations, and each citation keeps its claim identifier, so every cited statement can be traced back to a verified claim and its source. The same run saved a BibTeX file, a searchable vector index and the full trace.
+In the code, the logic behind these panels lives in a few places: the ReAct step and its validation in planner.py, the entailment check in critic.py, and the atomic subtask-claiming transaction, claim_subtask, in blackboard.py.
+All of the evidence that the system works is in my public GitHub repository, shown at the bottom of the slide. The evidence/runs folder holds the terminal logs, reports, BibTeX files and traces of the live runs, including this one. The evidence/screenshots folder has ten dashboard screenshots, evidence/tests has the full test-suite output with coverage, evidence/evaluation has the benchmark results, and docs/REMEDIATION_LOG.md records every defect found and fixed. Section nine of the README maps each piece of evidence to its file, and the README explains how to run the system yourself.</a:t>
             </a:r>
             <a:endParaRPr lang="en-US" dirty="0"/>
           </a:p>
@@ -1627,8 +1623,8 @@
             <a:r>
               <a:rPr lang="en-US" dirty="0"/>
               <a:t>The Unit 6 feedback asked for clear, measurable targets: test queries, deduplication thresholds, and Critic precision and recall. I set these targets before running anything.
-First, the Critic. I hand-labelled 21 claim-source pairs: twelve supported, and nine hallucinations of six kinds, including over-generalisation, wrong entities, fabricated numbers, metric shifts and contradictions. The targets were precision of at least 0.85 and recall of at least 0.75. The chart compares three verifiers. A simple word-overlap baseline reaches only 0.83 and misses contradictions and metric shifts, because those reuse the source's own words. The production Critic, Qwen, and the fallback, gpt-oss-120b, both scored 1.0 on precision and recall, catching all nine hallucinations. That comparison is the empirical justification for using an LLM as the judge rather than string matching. I'll be honest about the limit, though: 21 items is small, and a perfect score is more likely a ceiling effect than proof of perfection.
-Second, retrieval. I used ten fixed queries whose target papers are the ones our own Unit 6 report cited, in effect asking whether ScholarPlan can find the literature its design relied on. Recall was 0.9 against a target of 0.75. No single API found everything: arXiv found seven, OpenAlex six and Crossref one, which supports the decision to query all three. The one miss, Hayes-Roth 1985, has no indexed abstract, and the system deliberately excludes records it cannot verify. That is a real trade-off: verifiability versus coverage of older work.
+First, the Critic. I hand-labelled 21 claim-source pairs: twelve supported, and nine hallucinations of seven kinds, including over-generalisation, wrong entities, fabricated numbers, metric shifts and contradictions. The targets were precision of at least 0.85 and recall of at least 0.75. The chart compares three verifiers. A simple word-overlap baseline reaches only 0.83 and misses contradictions and metric shifts, because those reuse the source's own words. The production Critic, Qwen, and the fallback, gpt-oss-120b, both scored 1.0 on precision and recall, catching all nine hallucinations. That comparison is the empirical justification for using an LLM as the judge rather than string matching. I'll be honest about the limit, though: 21 items is small, and a perfect score is more likely a ceiling effect than proof of perfection.
+Second, retrieval. I used ten fixed queries whose target papers are the ones our own Unit 6 report cited, in effect asking whether ScholarPlan can find the literature its design relied on. Recall was 0.9 against a target of 0.75. No single API found everything: arXiv found eight, OpenAlex six and Crossref one, which supports the decision to query all three. The one miss, Hayes-Roth 1985, has no indexed abstract, and the system deliberately excludes records it cannot verify. That is a real trade-off: verifiability versus coverage of older work.
 Third, end-to-end. Three fixed goals, live: all three completed within the twenty-step budget, using 6.7 steps and under a minute on average, and about 21,000 tokens per run, comfortably inside the free tier.
 The deduplication and relevance thresholds, 0.92 and 0.30 cosine similarity, are named constants and are unit-tested in both directions.</a:t>
             </a:r>
@@ -1718,10 +1714,10 @@
           <a:p>
             <a:r>
               <a:rPr lang="en-US" dirty="0"/>
-              <a:t>Testing followed the Unit 6 plan of testing by agent type. Deterministic components have conventional unit tests: 82 of them, covering blackboard atomicity and permissions, API parsers run against recorded real responses, rate limiting and retries, the thresholds, Planner rules and citation formatting. Twelve functional tests run the whole system end to end, offline, and each one forces a specific behaviour: Critic rejection leading to re-planning, the three-re-plan cap, budget exhaustion, an injected hallucination being filtered, and an API failing mid-run. Four live smoke tests detect drift in the external services. Overall: 94 passing tests and 93 percent line coverage.
+              <a:t>Testing followed the Unit 6 plan of testing by agent type. Deterministic components have conventional unit tests: 84 of them, covering blackboard atomicity and permissions, API parsers run against recorded real responses, rate limiting and retries, the thresholds, Planner rules and citation formatting. Twelve functional tests run the whole system end to end, offline, and each one forces a specific behaviour: Critic rejection leading to re-planning, the three-re-plan cap, budget exhaustion, an injected hallucination being filtered, and an API failing mid-run. Four live smoke tests detect drift in the external services. Overall: 96 passing tests and 92 percent line coverage.
 The scripted mock LLM is what makes this possible: a real model will not reject claims on demand, but a scripted one can, deterministically.
-Every defect is recorded in a remediation log, nineteen in total, each with its root cause, fix and verifying test. Three stand out. The Critic model chosen in Unit 6 was withdrawn by the provider, so I added an automatic model-substitution mechanism and a regression test. OpenAlex returned "too many requests" errors in the first live run, so the client now honours the server's retry-after header. And most interesting: in a live run, the Planner misdiagnosed a model formatting error as a bad query and rewrote a perfectly good query, because the feedback message did not state the cause. The lesson is that Reflexion-style self-correction is only as good as its feedback signal, so feedback now carries the diagnosis.
-Progress is visible in the Git history: from the Unit 6 design, through seven short sprints, each ending in a tested increment.</a:t>
+Every defect is recorded in a remediation log, twenty in total, each with its root cause, fix and verifying test. Three stand out. The Critic model chosen in Unit 6 was withdrawn by the provider, so I added an automatic model-substitution mechanism and a regression test. OpenAlex returned "too many requests" errors in the first live run, so the client now honours the server's retry-after header. And most interesting: in a live run, the Planner misdiagnosed a model formatting error as a bad query and rewrote a perfectly good query, because the feedback message did not state the cause. The lesson is that Reflexion-style self-correction is only as good as its feedback signal, so feedback now carries the diagnosis.
+Progress is visible in the Git history: from the Unit 6 design, through eight short sprints, Sprint 0 to Sprint 7, each ending in a tested increment.</a:t>
             </a:r>
             <a:endParaRPr lang="en-US" dirty="0"/>
           </a:p>
@@ -3559,7 +3555,7 @@
                   <a:srgbClr val="CBD5E1"/>
                 </a:solidFill>
               </a:rPr>
-              <a:t>Independent Critic: P = R = 1.00 on the benchmark; caught the planted claim live</a:t>
+              <a:t>Independent Critic: P = R = 1.00 on the benchmark; caught a planted claim in a live run</a:t>
             </a:r>
             <a:endParaRPr lang="en-US" sz="1700" dirty="0"/>
           </a:p>
@@ -5482,7 +5478,7 @@
                 <a:ea typeface="Cambria" pitchFamily="34" charset="-122"/>
                 <a:cs typeface="Cambria" pitchFamily="34" charset="-120"/>
               </a:rPr>
-              <a:t>94</a:t>
+              <a:t>96</a:t>
             </a:r>
             <a:endParaRPr lang="en-US" sz="3400" dirty="0"/>
           </a:p>
@@ -5518,7 +5514,7 @@
                   <a:schemeClr val="tx2"/>
                 </a:solidFill>
               </a:rPr>
-              <a:t>automated tests · 93% coverage</a:t>
+              <a:t>automated tests · 92% coverage</a:t>
             </a:r>
             <a:endParaRPr lang="en-US" sz="1200" dirty="0"/>
           </a:p>
@@ -6122,7 +6118,7 @@
         </p:nvSpPr>
         <p:spPr>
           <a:xfrm>
-            <a:off x="548640" y="2606040"/>
+            <a:off x="457200" y="2606040"/>
             <a:ext cx="1691640" cy="1143000"/>
           </a:xfrm>
           <a:prstGeom prst="roundRect">
@@ -6149,7 +6145,7 @@
         </p:nvSpPr>
         <p:spPr>
           <a:xfrm>
-            <a:off x="658368" y="2743200"/>
+            <a:off x="566928" y="2743200"/>
             <a:ext cx="502920" cy="502920"/>
           </a:xfrm>
           <a:prstGeom prst="ellipse">
@@ -6182,7 +6178,7 @@
         </p:blipFill>
         <p:spPr>
           <a:xfrm>
-            <a:off x="789127" y="2873959"/>
+            <a:off x="697687" y="2873959"/>
             <a:ext cx="241402" cy="241402"/>
           </a:xfrm>
           <a:prstGeom prst="rect">
@@ -6198,7 +6194,7 @@
         </p:nvSpPr>
         <p:spPr>
           <a:xfrm>
-            <a:off x="1234440" y="2715768"/>
+            <a:off x="1143000" y="2715768"/>
             <a:ext cx="914400" cy="320040"/>
           </a:xfrm>
           <a:prstGeom prst="rect">
@@ -6234,7 +6230,7 @@
         </p:nvSpPr>
         <p:spPr>
           <a:xfrm>
-            <a:off x="658368" y="3264408"/>
+            <a:off x="566928" y="3264408"/>
             <a:ext cx="1508760" cy="457200"/>
           </a:xfrm>
           <a:prstGeom prst="rect">
@@ -6795,8 +6791,8 @@
         </p:nvSpPr>
         <p:spPr>
           <a:xfrm>
-            <a:off x="2240280" y="3182112"/>
-            <a:ext cx="91440" cy="0"/>
+            <a:off x="2148840" y="3182112"/>
+            <a:ext cx="182880" cy="0"/>
           </a:xfrm>
           <a:prstGeom prst="line">
             <a:avLst/>
@@ -6845,7 +6841,7 @@
         </p:nvSpPr>
         <p:spPr>
           <a:xfrm>
-            <a:off x="2286000" y="4206240"/>
+            <a:off x="2743200" y="4206240"/>
             <a:ext cx="0" cy="320040"/>
           </a:xfrm>
           <a:prstGeom prst="line">
@@ -9379,8 +9375,8 @@
         </p:nvSpPr>
         <p:spPr>
           <a:xfrm>
-            <a:off x="4663440" y="2103120"/>
-            <a:ext cx="0" cy="292608"/>
+            <a:off x="4663440" y="2231136"/>
+            <a:ext cx="0" cy="164592"/>
           </a:xfrm>
           <a:prstGeom prst="line">
             <a:avLst/>
@@ -9391,13 +9387,37 @@
               <a:srgbClr val="475569"/>
             </a:solidFill>
             <a:prstDash val="solid"/>
-            <a:headEnd type="triangle"/>
           </a:ln>
         </p:spPr>
       </p:sp>
       <p:sp>
         <p:nvSpPr>
-          <p:cNvPr id="25" name="Shape 23"/>
+          <p:cNvPr id="25" name="generalisation arrowhead"/>
+          <p:cNvSpPr/>
+          <p:nvPr/>
+        </p:nvSpPr>
+        <p:spPr>
+          <a:xfrm>
+            <a:off x="4572000" y="2103120"/>
+            <a:ext cx="182880" cy="137160"/>
+          </a:xfrm>
+          <a:prstGeom prst="triangle">
+            <a:avLst/>
+          </a:prstGeom>
+          <a:solidFill>
+            <a:srgbClr val="FFFFFF"/>
+          </a:solidFill>
+          <a:ln w="15875">
+            <a:solidFill>
+              <a:srgbClr val="475569"/>
+            </a:solidFill>
+            <a:prstDash val="solid"/>
+          </a:ln>
+        </p:spPr>
+      </p:sp>
+      <p:sp>
+        <p:nvSpPr>
+          <p:cNvPr id="26" name="Shape 24"/>
           <p:cNvSpPr/>
           <p:nvPr/>
         </p:nvSpPr>
@@ -9420,7 +9440,7 @@
       </p:sp>
       <p:sp>
         <p:nvSpPr>
-          <p:cNvPr id="26" name="Shape 24"/>
+          <p:cNvPr id="27" name="Shape 25"/>
           <p:cNvSpPr/>
           <p:nvPr/>
         </p:nvSpPr>
@@ -9443,7 +9463,7 @@
       </p:sp>
       <p:sp>
         <p:nvSpPr>
-          <p:cNvPr id="27" name="Shape 25"/>
+          <p:cNvPr id="28" name="Shape 26"/>
           <p:cNvSpPr/>
           <p:nvPr/>
         </p:nvSpPr>
@@ -9468,7 +9488,7 @@
       </p:sp>
       <p:sp>
         <p:nvSpPr>
-          <p:cNvPr id="28" name="Shape 26"/>
+          <p:cNvPr id="29" name="Shape 27"/>
           <p:cNvSpPr/>
           <p:nvPr/>
         </p:nvSpPr>
@@ -9493,7 +9513,7 @@
       </p:sp>
       <p:sp>
         <p:nvSpPr>
-          <p:cNvPr id="29" name="Text 27"/>
+          <p:cNvPr id="30" name="Text 28"/>
           <p:cNvSpPr txBox="1"/>
           <p:nvPr/>
         </p:nvSpPr>
@@ -9529,7 +9549,7 @@
       </p:sp>
       <p:sp>
         <p:nvSpPr>
-          <p:cNvPr id="30" name="Text 28"/>
+          <p:cNvPr id="31" name="Text 29"/>
           <p:cNvSpPr txBox="1"/>
           <p:nvPr/>
         </p:nvSpPr>
@@ -9585,7 +9605,7 @@
       </p:sp>
       <p:sp>
         <p:nvSpPr>
-          <p:cNvPr id="31" name="Shape 29"/>
+          <p:cNvPr id="32" name="Shape 30"/>
           <p:cNvSpPr/>
           <p:nvPr/>
         </p:nvSpPr>
@@ -9608,7 +9628,7 @@
       </p:sp>
       <p:sp>
         <p:nvSpPr>
-          <p:cNvPr id="32" name="Shape 30"/>
+          <p:cNvPr id="33" name="Shape 31"/>
           <p:cNvSpPr/>
           <p:nvPr/>
         </p:nvSpPr>
@@ -9633,7 +9653,7 @@
       </p:sp>
       <p:sp>
         <p:nvSpPr>
-          <p:cNvPr id="33" name="Shape 31"/>
+          <p:cNvPr id="34" name="Shape 32"/>
           <p:cNvSpPr/>
           <p:nvPr/>
         </p:nvSpPr>
@@ -9658,7 +9678,7 @@
       </p:sp>
       <p:sp>
         <p:nvSpPr>
-          <p:cNvPr id="34" name="Text 32"/>
+          <p:cNvPr id="35" name="Text 33"/>
           <p:cNvSpPr txBox="1"/>
           <p:nvPr/>
         </p:nvSpPr>
@@ -9694,7 +9714,7 @@
       </p:sp>
       <p:sp>
         <p:nvSpPr>
-          <p:cNvPr id="35" name="Text 33"/>
+          <p:cNvPr id="36" name="Text 34"/>
           <p:cNvSpPr txBox="1"/>
           <p:nvPr/>
         </p:nvSpPr>
@@ -9750,7 +9770,7 @@
       </p:sp>
       <p:sp>
         <p:nvSpPr>
-          <p:cNvPr id="36" name="Shape 34"/>
+          <p:cNvPr id="37" name="Shape 35"/>
           <p:cNvSpPr/>
           <p:nvPr/>
         </p:nvSpPr>
@@ -9773,7 +9793,7 @@
       </p:sp>
       <p:sp>
         <p:nvSpPr>
-          <p:cNvPr id="37" name="Shape 35"/>
+          <p:cNvPr id="38" name="Shape 36"/>
           <p:cNvSpPr/>
           <p:nvPr/>
         </p:nvSpPr>
@@ -9798,7 +9818,7 @@
       </p:sp>
       <p:sp>
         <p:nvSpPr>
-          <p:cNvPr id="38" name="Shape 36"/>
+          <p:cNvPr id="39" name="Shape 37"/>
           <p:cNvSpPr/>
           <p:nvPr/>
         </p:nvSpPr>
@@ -9823,7 +9843,7 @@
       </p:sp>
       <p:sp>
         <p:nvSpPr>
-          <p:cNvPr id="39" name="Text 37"/>
+          <p:cNvPr id="40" name="Text 38"/>
           <p:cNvSpPr txBox="1"/>
           <p:nvPr/>
         </p:nvSpPr>
@@ -9859,7 +9879,7 @@
       </p:sp>
       <p:sp>
         <p:nvSpPr>
-          <p:cNvPr id="40" name="Text 38"/>
+          <p:cNvPr id="41" name="Text 39"/>
           <p:cNvSpPr txBox="1"/>
           <p:nvPr/>
         </p:nvSpPr>
@@ -9915,7 +9935,7 @@
       </p:sp>
       <p:sp>
         <p:nvSpPr>
-          <p:cNvPr id="41" name="Shape 39"/>
+          <p:cNvPr id="42" name="Shape 40"/>
           <p:cNvSpPr/>
           <p:nvPr/>
         </p:nvSpPr>
@@ -9938,7 +9958,7 @@
       </p:sp>
       <p:sp>
         <p:nvSpPr>
-          <p:cNvPr id="42" name="Shape 40"/>
+          <p:cNvPr id="43" name="Shape 41"/>
           <p:cNvSpPr/>
           <p:nvPr/>
         </p:nvSpPr>
@@ -9963,7 +9983,7 @@
       </p:sp>
       <p:sp>
         <p:nvSpPr>
-          <p:cNvPr id="43" name="Shape 41"/>
+          <p:cNvPr id="44" name="Shape 42"/>
           <p:cNvSpPr/>
           <p:nvPr/>
         </p:nvSpPr>
@@ -9988,7 +10008,7 @@
       </p:sp>
       <p:sp>
         <p:nvSpPr>
-          <p:cNvPr id="44" name="Text 42"/>
+          <p:cNvPr id="45" name="Text 43"/>
           <p:cNvSpPr txBox="1"/>
           <p:nvPr/>
         </p:nvSpPr>
@@ -10024,7 +10044,7 @@
       </p:sp>
       <p:sp>
         <p:nvSpPr>
-          <p:cNvPr id="45" name="Text 43"/>
+          <p:cNvPr id="46" name="Text 44"/>
           <p:cNvSpPr txBox="1"/>
           <p:nvPr/>
         </p:nvSpPr>
@@ -10080,7 +10100,7 @@
       </p:sp>
       <p:sp>
         <p:nvSpPr>
-          <p:cNvPr id="46" name="Shape 44"/>
+          <p:cNvPr id="47" name="Shape 45"/>
           <p:cNvSpPr/>
           <p:nvPr/>
         </p:nvSpPr>
@@ -10103,7 +10123,7 @@
       </p:sp>
       <p:sp>
         <p:nvSpPr>
-          <p:cNvPr id="47" name="Shape 45"/>
+          <p:cNvPr id="48" name="Shape 46"/>
           <p:cNvSpPr/>
           <p:nvPr/>
         </p:nvSpPr>
@@ -10128,7 +10148,7 @@
       </p:sp>
       <p:sp>
         <p:nvSpPr>
-          <p:cNvPr id="48" name="Shape 46"/>
+          <p:cNvPr id="49" name="Shape 47"/>
           <p:cNvSpPr/>
           <p:nvPr/>
         </p:nvSpPr>
@@ -10153,7 +10173,7 @@
       </p:sp>
       <p:sp>
         <p:nvSpPr>
-          <p:cNvPr id="49" name="Text 47"/>
+          <p:cNvPr id="50" name="Text 48"/>
           <p:cNvSpPr txBox="1"/>
           <p:nvPr/>
         </p:nvSpPr>
@@ -10189,7 +10209,7 @@
       </p:sp>
       <p:sp>
         <p:nvSpPr>
-          <p:cNvPr id="50" name="Text 48"/>
+          <p:cNvPr id="51" name="Text 49"/>
           <p:cNvSpPr txBox="1"/>
           <p:nvPr/>
         </p:nvSpPr>
@@ -10245,13 +10265,13 @@
       </p:sp>
       <p:sp>
         <p:nvSpPr>
-          <p:cNvPr id="51" name="Text 49"/>
-          <p:cNvSpPr txBox="1"/>
-          <p:nvPr/>
-        </p:nvSpPr>
-        <p:spPr>
-          <a:xfrm>
-            <a:off x="4754880" y="2121408"/>
+          <p:cNvPr id="52" name="Text 50"/>
+          <p:cNvSpPr txBox="1"/>
+          <p:nvPr/>
+        </p:nvSpPr>
+        <p:spPr>
+          <a:xfrm>
+            <a:off x="4846320" y="2121408"/>
             <a:ext cx="1097280" cy="228600"/>
           </a:xfrm>
           <a:prstGeom prst="rect">
@@ -10281,7 +10301,7 @@
       </p:sp>
       <p:sp>
         <p:nvSpPr>
-          <p:cNvPr id="52" name="Shape 50"/>
+          <p:cNvPr id="53" name="Shape 51"/>
           <p:cNvSpPr/>
           <p:nvPr/>
         </p:nvSpPr>
@@ -10306,7 +10326,7 @@
       </p:sp>
       <p:sp>
         <p:nvSpPr>
-          <p:cNvPr id="53" name="Text 51"/>
+          <p:cNvPr id="54" name="Text 52"/>
           <p:cNvSpPr txBox="1"/>
           <p:nvPr/>
         </p:nvSpPr>
@@ -10342,7 +10362,7 @@
       </p:sp>
       <p:sp>
         <p:nvSpPr>
-          <p:cNvPr id="54" name="Shape 52"/>
+          <p:cNvPr id="55" name="Shape 53"/>
           <p:cNvSpPr/>
           <p:nvPr/>
         </p:nvSpPr>
@@ -10367,7 +10387,7 @@
       </p:sp>
       <p:sp>
         <p:nvSpPr>
-          <p:cNvPr id="55" name="Shape 53"/>
+          <p:cNvPr id="56" name="Shape 54"/>
           <p:cNvSpPr/>
           <p:nvPr/>
         </p:nvSpPr>
@@ -10392,7 +10412,7 @@
       </p:sp>
       <p:sp>
         <p:nvSpPr>
-          <p:cNvPr id="56" name="Text 54"/>
+          <p:cNvPr id="57" name="Text 55"/>
           <p:cNvSpPr txBox="1"/>
           <p:nvPr/>
         </p:nvSpPr>
@@ -10439,7 +10459,7 @@
       </p:sp>
       <p:sp>
         <p:nvSpPr>
-          <p:cNvPr id="57" name="Text 55"/>
+          <p:cNvPr id="58" name="Text 56"/>
           <p:cNvSpPr txBox="1"/>
           <p:nvPr/>
         </p:nvSpPr>
@@ -10478,7 +10498,7 @@
       </p:sp>
       <p:sp>
         <p:nvSpPr>
-          <p:cNvPr id="58" name="Shape 56"/>
+          <p:cNvPr id="59" name="Shape 57"/>
           <p:cNvSpPr/>
           <p:nvPr/>
         </p:nvSpPr>
@@ -10503,7 +10523,7 @@
       </p:sp>
       <p:sp>
         <p:nvSpPr>
-          <p:cNvPr id="59" name="Shape 57"/>
+          <p:cNvPr id="60" name="Shape 58"/>
           <p:cNvSpPr/>
           <p:nvPr/>
         </p:nvSpPr>
@@ -10528,7 +10548,7 @@
       </p:sp>
       <p:sp>
         <p:nvSpPr>
-          <p:cNvPr id="60" name="Text 58"/>
+          <p:cNvPr id="61" name="Text 59"/>
           <p:cNvSpPr txBox="1"/>
           <p:nvPr/>
         </p:nvSpPr>
@@ -10564,7 +10584,7 @@
       </p:sp>
       <p:sp>
         <p:nvSpPr>
-          <p:cNvPr id="61" name="Text 59"/>
+          <p:cNvPr id="62" name="Text 60"/>
           <p:cNvSpPr txBox="1"/>
           <p:nvPr/>
         </p:nvSpPr>
@@ -10603,7 +10623,7 @@
       </p:sp>
       <p:sp>
         <p:nvSpPr>
-          <p:cNvPr id="62" name="Shape 60"/>
+          <p:cNvPr id="63" name="Shape 61"/>
           <p:cNvSpPr/>
           <p:nvPr/>
         </p:nvSpPr>
@@ -10628,7 +10648,7 @@
       </p:sp>
       <p:sp>
         <p:nvSpPr>
-          <p:cNvPr id="63" name="Shape 61"/>
+          <p:cNvPr id="64" name="Shape 62"/>
           <p:cNvSpPr/>
           <p:nvPr/>
         </p:nvSpPr>
@@ -10653,7 +10673,7 @@
       </p:sp>
       <p:sp>
         <p:nvSpPr>
-          <p:cNvPr id="64" name="Text 62"/>
+          <p:cNvPr id="65" name="Text 63"/>
           <p:cNvSpPr txBox="1"/>
           <p:nvPr/>
         </p:nvSpPr>
@@ -10689,7 +10709,7 @@
       </p:sp>
       <p:sp>
         <p:nvSpPr>
-          <p:cNvPr id="65" name="Text 63"/>
+          <p:cNvPr id="66" name="Text 64"/>
           <p:cNvSpPr txBox="1"/>
           <p:nvPr/>
         </p:nvSpPr>
@@ -10728,7 +10748,7 @@
       </p:sp>
       <p:sp>
         <p:nvSpPr>
-          <p:cNvPr id="66" name="Shape 64"/>
+          <p:cNvPr id="67" name="Shape 65"/>
           <p:cNvSpPr/>
           <p:nvPr/>
         </p:nvSpPr>
@@ -10753,7 +10773,7 @@
       </p:sp>
       <p:sp>
         <p:nvSpPr>
-          <p:cNvPr id="67" name="Shape 65"/>
+          <p:cNvPr id="68" name="Shape 66"/>
           <p:cNvSpPr/>
           <p:nvPr/>
         </p:nvSpPr>
@@ -10778,7 +10798,7 @@
       </p:sp>
       <p:sp>
         <p:nvSpPr>
-          <p:cNvPr id="68" name="Text 66"/>
+          <p:cNvPr id="69" name="Text 67"/>
           <p:cNvSpPr txBox="1"/>
           <p:nvPr/>
         </p:nvSpPr>
@@ -10814,7 +10834,7 @@
       </p:sp>
       <p:sp>
         <p:nvSpPr>
-          <p:cNvPr id="69" name="Text 67"/>
+          <p:cNvPr id="70" name="Text 68"/>
           <p:cNvSpPr txBox="1"/>
           <p:nvPr/>
         </p:nvSpPr>
@@ -10853,7 +10873,7 @@
       </p:sp>
       <p:sp>
         <p:nvSpPr>
-          <p:cNvPr id="70" name="Shape 68"/>
+          <p:cNvPr id="71" name="Shape 69"/>
           <p:cNvSpPr/>
           <p:nvPr/>
         </p:nvSpPr>
@@ -10878,7 +10898,7 @@
       </p:sp>
       <p:sp>
         <p:nvSpPr>
-          <p:cNvPr id="71" name="Text 69"/>
+          <p:cNvPr id="72" name="Text 70"/>
           <p:cNvSpPr txBox="1"/>
           <p:nvPr/>
         </p:nvSpPr>
@@ -10914,7 +10934,7 @@
       </p:sp>
       <p:sp>
         <p:nvSpPr>
-          <p:cNvPr id="72" name="Shape 70"/>
+          <p:cNvPr id="73" name="Shape 71"/>
           <p:cNvSpPr/>
           <p:nvPr/>
         </p:nvSpPr>
@@ -10939,7 +10959,7 @@
       </p:sp>
       <p:sp>
         <p:nvSpPr>
-          <p:cNvPr id="73" name="Shape 71"/>
+          <p:cNvPr id="74" name="Shape 72"/>
           <p:cNvSpPr/>
           <p:nvPr/>
         </p:nvSpPr>
@@ -10964,7 +10984,7 @@
       </p:sp>
       <p:sp>
         <p:nvSpPr>
-          <p:cNvPr id="74" name="Text 72"/>
+          <p:cNvPr id="75" name="Text 73"/>
           <p:cNvSpPr txBox="1"/>
           <p:nvPr/>
         </p:nvSpPr>
@@ -11011,7 +11031,7 @@
       </p:sp>
       <p:sp>
         <p:nvSpPr>
-          <p:cNvPr id="75" name="Text 73"/>
+          <p:cNvPr id="76" name="Text 74"/>
           <p:cNvSpPr txBox="1"/>
           <p:nvPr/>
         </p:nvSpPr>
@@ -11050,7 +11070,7 @@
       </p:sp>
       <p:sp>
         <p:nvSpPr>
-          <p:cNvPr id="76" name="Shape 74"/>
+          <p:cNvPr id="77" name="Shape 75"/>
           <p:cNvSpPr/>
           <p:nvPr/>
         </p:nvSpPr>
@@ -11075,7 +11095,7 @@
       </p:sp>
       <p:sp>
         <p:nvSpPr>
-          <p:cNvPr id="77" name="Shape 75"/>
+          <p:cNvPr id="78" name="Shape 76"/>
           <p:cNvSpPr/>
           <p:nvPr/>
         </p:nvSpPr>
@@ -11100,7 +11120,7 @@
       </p:sp>
       <p:sp>
         <p:nvSpPr>
-          <p:cNvPr id="78" name="Text 76"/>
+          <p:cNvPr id="79" name="Text 77"/>
           <p:cNvSpPr txBox="1"/>
           <p:nvPr/>
         </p:nvSpPr>
@@ -11136,7 +11156,7 @@
       </p:sp>
       <p:sp>
         <p:nvSpPr>
-          <p:cNvPr id="79" name="Text 77"/>
+          <p:cNvPr id="80" name="Text 78"/>
           <p:cNvSpPr txBox="1"/>
           <p:nvPr/>
         </p:nvSpPr>
@@ -11175,7 +11195,7 @@
       </p:sp>
       <p:sp>
         <p:nvSpPr>
-          <p:cNvPr id="80" name="Shape 78"/>
+          <p:cNvPr id="81" name="Shape 79"/>
           <p:cNvSpPr/>
           <p:nvPr/>
         </p:nvSpPr>
@@ -11200,7 +11220,7 @@
       </p:sp>
       <p:sp>
         <p:nvSpPr>
-          <p:cNvPr id="81" name="Text 79"/>
+          <p:cNvPr id="82" name="Text 80"/>
           <p:cNvSpPr txBox="1"/>
           <p:nvPr/>
         </p:nvSpPr>
@@ -11236,7 +11256,7 @@
       </p:sp>
       <p:sp>
         <p:nvSpPr>
-          <p:cNvPr id="82" name="Shape 80"/>
+          <p:cNvPr id="83" name="Shape 81"/>
           <p:cNvSpPr/>
           <p:nvPr/>
         </p:nvSpPr>
@@ -11261,7 +11281,7 @@
       </p:sp>
       <p:sp>
         <p:nvSpPr>
-          <p:cNvPr id="83" name="Shape 81"/>
+          <p:cNvPr id="84" name="Shape 82"/>
           <p:cNvSpPr/>
           <p:nvPr/>
         </p:nvSpPr>
@@ -11286,7 +11306,7 @@
       </p:sp>
       <p:sp>
         <p:nvSpPr>
-          <p:cNvPr id="84" name="Text 82"/>
+          <p:cNvPr id="85" name="Text 83"/>
           <p:cNvSpPr txBox="1"/>
           <p:nvPr/>
         </p:nvSpPr>
@@ -11322,7 +11342,7 @@
       </p:sp>
       <p:sp>
         <p:nvSpPr>
-          <p:cNvPr id="85" name="Text 83"/>
+          <p:cNvPr id="86" name="Text 84"/>
           <p:cNvSpPr txBox="1"/>
           <p:nvPr/>
         </p:nvSpPr>
@@ -11361,7 +11381,7 @@
       </p:sp>
       <p:sp>
         <p:nvSpPr>
-          <p:cNvPr id="86" name="Shape 84"/>
+          <p:cNvPr id="87" name="Shape 85"/>
           <p:cNvSpPr/>
           <p:nvPr/>
         </p:nvSpPr>
@@ -11386,7 +11406,7 @@
       </p:sp>
       <p:sp>
         <p:nvSpPr>
-          <p:cNvPr id="87" name="Shape 85"/>
+          <p:cNvPr id="88" name="Shape 86"/>
           <p:cNvSpPr/>
           <p:nvPr/>
         </p:nvSpPr>
@@ -11411,7 +11431,7 @@
       </p:sp>
       <p:sp>
         <p:nvSpPr>
-          <p:cNvPr id="88" name="Text 86"/>
+          <p:cNvPr id="89" name="Text 87"/>
           <p:cNvSpPr txBox="1"/>
           <p:nvPr/>
         </p:nvSpPr>
@@ -11447,7 +11467,7 @@
       </p:sp>
       <p:sp>
         <p:nvSpPr>
-          <p:cNvPr id="89" name="Text 87"/>
+          <p:cNvPr id="90" name="Text 88"/>
           <p:cNvSpPr txBox="1"/>
           <p:nvPr/>
         </p:nvSpPr>
@@ -11486,7 +11506,7 @@
       </p:sp>
       <p:sp>
         <p:nvSpPr>
-          <p:cNvPr id="90" name="Shape 88"/>
+          <p:cNvPr id="91" name="Shape 89"/>
           <p:cNvSpPr/>
           <p:nvPr/>
         </p:nvSpPr>
@@ -11511,7 +11531,7 @@
       </p:sp>
       <p:sp>
         <p:nvSpPr>
-          <p:cNvPr id="91" name="Shape 89"/>
+          <p:cNvPr id="92" name="Shape 90"/>
           <p:cNvSpPr/>
           <p:nvPr/>
         </p:nvSpPr>
@@ -11536,7 +11556,7 @@
       </p:sp>
       <p:sp>
         <p:nvSpPr>
-          <p:cNvPr id="92" name="Text 90"/>
+          <p:cNvPr id="93" name="Text 91"/>
           <p:cNvSpPr txBox="1"/>
           <p:nvPr/>
         </p:nvSpPr>
@@ -11583,7 +11603,7 @@
       </p:sp>
       <p:sp>
         <p:nvSpPr>
-          <p:cNvPr id="93" name="Text 91"/>
+          <p:cNvPr id="94" name="Text 92"/>
           <p:cNvSpPr txBox="1"/>
           <p:nvPr/>
         </p:nvSpPr>
@@ -11622,7 +11642,7 @@
       </p:sp>
       <p:sp>
         <p:nvSpPr>
-          <p:cNvPr id="94" name="Text 92"/>
+          <p:cNvPr id="95" name="Text 93"/>
           <p:cNvSpPr txBox="1"/>
           <p:nvPr/>
         </p:nvSpPr>
@@ -11650,7 +11670,7 @@
                   <a:srgbClr val="64748B"/>
                 </a:solidFill>
               </a:rPr>
-              <a:t>◆ aggregation (Controller holds 5 agents)   ▲ generalisation (5 roles inherit Agent)   ⇢ dependency (listed in each class)</a:t>
+              <a:t>◆ composition (Controller creates and owns its 5 agents)   △ generalisation (5 roles inherit Agent)   ⇢ dependency (listed in each class)</a:t>
             </a:r>
             <a:endParaRPr lang="en-US" sz="1000" dirty="0"/>
           </a:p>
@@ -11761,7 +11781,7 @@
                 <a:ea typeface="Cambria" pitchFamily="34" charset="-122"/>
                 <a:cs typeface="Cambria" pitchFamily="34" charset="-120"/>
               </a:rPr>
-              <a:t>Live demonstration</a:t>
+              <a:t>Demonstration: live runs, step by step</a:t>
             </a:r>
             <a:endParaRPr lang="en-US" sz="3200" dirty="0"/>
           </a:p>
@@ -11775,33 +11795,123 @@
         </p:nvSpPr>
         <p:spPr>
           <a:xfrm>
-            <a:off x="548640" y="1234440"/>
-            <a:ext cx="6949440" cy="4343400"/>
-          </a:xfrm>
-          <a:prstGeom prst="rect">
-            <a:avLst/>
-          </a:prstGeom>
-          <a:solidFill>
-            <a:srgbClr val="1E293B"/>
+            <a:off x="548640" y="1207008"/>
+            <a:ext cx="274320" cy="274320"/>
+          </a:xfrm>
+          <a:prstGeom prst="ellipse">
+            <a:avLst/>
+          </a:prstGeom>
+          <a:solidFill>
+            <a:srgbClr val="2563EB"/>
           </a:solidFill>
           <a:ln w="12700">
             <a:solidFill>
-              <a:srgbClr val="475569"/>
+              <a:srgbClr val="2563EB"/>
             </a:solidFill>
             <a:prstDash val="solid"/>
           </a:ln>
-          <a:effectLst>
-            <a:outerShdw sx="100000" sy="100000" kx="0" ky="0" algn="bl" rotWithShape="0" blurRad="101600" dist="38100" dir="5400000">
-              <a:srgbClr val="000000">
-                <a:alpha val="40000"/>
-              </a:srgbClr>
-            </a:outerShdw>
-          </a:effectLst>
+        </p:spPr>
+      </p:sp>
+      <p:sp>
+        <p:nvSpPr>
+          <p:cNvPr id="4" name="Text 2"/>
+          <p:cNvSpPr txBox="1"/>
+          <p:nvPr/>
+        </p:nvSpPr>
+        <p:spPr>
+          <a:xfrm>
+            <a:off x="548640" y="1207008"/>
+            <a:ext cx="274320" cy="274320"/>
+          </a:xfrm>
+          <a:prstGeom prst="rect">
+            <a:avLst/>
+          </a:prstGeom>
+          <a:noFill/>
+          <a:ln/>
+        </p:spPr>
+        <p:txBody>
+          <a:bodyPr wrap="square" lIns="0" tIns="0" rIns="0" bIns="0" rtlCol="0" anchor="ctr"/>
+          <a:lstStyle/>
+          <a:p>
+            <a:pPr algn="ctr" indent="0" marL="0">
+              <a:buNone/>
+            </a:pPr>
+            <a:r>
+              <a:rPr lang="en-US" sz="1200" b="1" dirty="0">
+                <a:solidFill>
+                  <a:srgbClr val="FFFFFF"/>
+                </a:solidFill>
+              </a:rPr>
+              <a:t>1</a:t>
+            </a:r>
+            <a:endParaRPr lang="en-US" sz="1200" dirty="0"/>
+          </a:p>
+        </p:txBody>
+      </p:sp>
+      <p:sp>
+        <p:nvSpPr>
+          <p:cNvPr id="5" name="Text 3"/>
+          <p:cNvSpPr txBox="1"/>
+          <p:nvPr/>
+        </p:nvSpPr>
+        <p:spPr>
+          <a:xfrm>
+            <a:off x="914400" y="1188720"/>
+            <a:ext cx="5074920" cy="310896"/>
+          </a:xfrm>
+          <a:prstGeom prst="rect">
+            <a:avLst/>
+          </a:prstGeom>
+          <a:noFill/>
+          <a:ln/>
+        </p:spPr>
+        <p:txBody>
+          <a:bodyPr wrap="square" lIns="0" tIns="0" rIns="0" bIns="0" rtlCol="0" anchor="ctr"/>
+          <a:lstStyle/>
+          <a:p>
+            <a:pPr indent="0" marL="0">
+              <a:buNone/>
+            </a:pPr>
+            <a:r>
+              <a:rPr lang="en-US" sz="1300" b="1" dirty="0">
+                <a:solidFill>
+                  <a:srgbClr val="E2E8F0"/>
+                </a:solidFill>
+              </a:rPr>
+              <a:t>Planner reasons, then acts: Thought → create_plan → issue_subtask</a:t>
+            </a:r>
+            <a:endParaRPr lang="en-US" sz="1300" dirty="0"/>
+          </a:p>
+        </p:txBody>
+      </p:sp>
+      <p:sp>
+        <p:nvSpPr>
+          <p:cNvPr id="6" name="panel 1 frame"/>
+          <p:cNvSpPr/>
+          <p:nvPr/>
+        </p:nvSpPr>
+        <p:spPr>
+          <a:xfrm>
+            <a:off x="548640" y="1517904"/>
+            <a:ext cx="5440680" cy="1965960"/>
+          </a:xfrm>
+          <a:prstGeom prst="rect">
+            <a:avLst/>
+          </a:prstGeom>
+          <a:solidFill>
+            <a:srgbClr val="0E1117"/>
+          </a:solidFill>
+          <a:ln w="12700">
+            <a:solidFill>
+              <a:srgbClr val="334155"/>
+            </a:solidFill>
+            <a:prstDash val="solid"/>
+          </a:ln>
         </p:spPr>
       </p:sp>
       <p:pic>
         <p:nvPicPr>
-          <p:cNvPr id="4" name="dashboard screenshot" descr="C:\Users\Adila\OneDrive\Documents\University\Adil\Intelligent Agents\scholarplan\evidence\screenshots\01_dashboard_trace.png">    </p:cNvPr>
+          <p:cNvPr id="7" name="panel 1 screenshot" descr="C:\Users\Adila\OneDrive\Documents\University\Adil\Intelligent Agents\scholarplan\presentation\assets\demo_1_plan.png">    </p:cNvPr>
           <p:cNvPicPr>
             <a:picLocks noChangeAspect="1"/>
           </p:cNvPicPr>
@@ -11815,8 +11925,8 @@
         </p:blipFill>
         <p:spPr>
           <a:xfrm>
-            <a:off x="548640" y="1234440"/>
-            <a:ext cx="6949440" cy="4343400"/>
+            <a:off x="603504" y="1581509"/>
+            <a:ext cx="5330952" cy="1838751"/>
           </a:xfrm>
           <a:prstGeom prst="rect">
             <a:avLst/>
@@ -11825,107 +11935,129 @@
       </p:pic>
       <p:sp>
         <p:nvSpPr>
-          <p:cNvPr id="5" name="Text 2"/>
-          <p:cNvSpPr txBox="1"/>
-          <p:nvPr/>
-        </p:nvSpPr>
-        <p:spPr>
-          <a:xfrm>
-            <a:off x="548640" y="5650992"/>
-            <a:ext cx="6949440" cy="274320"/>
-          </a:xfrm>
-          <a:prstGeom prst="rect">
-            <a:avLst/>
-          </a:prstGeom>
-          <a:noFill/>
-          <a:ln/>
-        </p:spPr>
-        <p:txBody>
-          <a:bodyPr wrap="square" lIns="0" tIns="0" rIns="0" bIns="0" rtlCol="0" anchor="ctr"/>
-          <a:lstStyle/>
-          <a:p>
-            <a:pPr indent="0" marL="0">
-              <a:buNone/>
-            </a:pPr>
-            <a:r>
-              <a:rPr lang="en-US" sz="1100" i="1" dirty="0">
-                <a:solidFill>
-                  <a:srgbClr val="94A3B8"/>
-                </a:solidFill>
-              </a:rPr>
-              <a:t>Streamlit dashboard reading the live blackboard · uv run scholarplan ui</a:t>
-            </a:r>
-            <a:endParaRPr lang="en-US" sz="1100" dirty="0"/>
-          </a:p>
-        </p:txBody>
-      </p:sp>
-      <p:sp>
-        <p:nvSpPr>
-          <p:cNvPr id="6" name="Text 3"/>
-          <p:cNvSpPr txBox="1"/>
-          <p:nvPr/>
-        </p:nvSpPr>
-        <p:spPr>
-          <a:xfrm>
-            <a:off x="7863840" y="1234440"/>
-            <a:ext cx="3749040" cy="411480"/>
-          </a:xfrm>
-          <a:prstGeom prst="rect">
-            <a:avLst/>
-          </a:prstGeom>
-          <a:noFill/>
-          <a:ln/>
-        </p:spPr>
-        <p:txBody>
-          <a:bodyPr wrap="square" lIns="0" tIns="0" rIns="0" bIns="0" rtlCol="0" anchor="ctr"/>
-          <a:lstStyle/>
-          <a:p>
-            <a:pPr indent="0" marL="0">
-              <a:buNone/>
-            </a:pPr>
-            <a:r>
-              <a:rPr lang="en-US" sz="2000" b="1" dirty="0">
-                <a:solidFill>
-                  <a:srgbClr val="F2A541"/>
-                </a:solidFill>
-                <a:latin typeface="Cambria" pitchFamily="34" charset="0"/>
-                <a:ea typeface="Cambria" pitchFamily="34" charset="-122"/>
-                <a:cs typeface="Cambria" pitchFamily="34" charset="-120"/>
-              </a:rPr>
-              <a:t>What to watch</a:t>
-            </a:r>
-            <a:endParaRPr lang="en-US" sz="2000" dirty="0"/>
-          </a:p>
-        </p:txBody>
-      </p:sp>
-      <p:sp>
-        <p:nvSpPr>
-          <p:cNvPr id="7" name="planner dot"/>
-          <p:cNvSpPr/>
-          <p:nvPr/>
-        </p:nvSpPr>
-        <p:spPr>
-          <a:xfrm>
-            <a:off x="7863840" y="1810512"/>
-            <a:ext cx="475488" cy="475488"/>
+          <p:cNvPr id="8" name="Shape 5"/>
+          <p:cNvSpPr/>
+          <p:nvPr/>
+        </p:nvSpPr>
+        <p:spPr>
+          <a:xfrm>
+            <a:off x="6172200" y="1207008"/>
+            <a:ext cx="274320" cy="274320"/>
           </a:xfrm>
           <a:prstGeom prst="ellipse">
             <a:avLst/>
           </a:prstGeom>
           <a:solidFill>
-            <a:srgbClr val="2563EB"/>
+            <a:srgbClr val="EA580C"/>
           </a:solidFill>
           <a:ln w="12700">
             <a:solidFill>
-              <a:srgbClr val="2563EB"/>
+              <a:srgbClr val="EA580C"/>
             </a:solidFill>
             <a:prstDash val="solid"/>
           </a:ln>
         </p:spPr>
       </p:sp>
+      <p:sp>
+        <p:nvSpPr>
+          <p:cNvPr id="9" name="Text 6"/>
+          <p:cNvSpPr txBox="1"/>
+          <p:nvPr/>
+        </p:nvSpPr>
+        <p:spPr>
+          <a:xfrm>
+            <a:off x="6172200" y="1207008"/>
+            <a:ext cx="274320" cy="274320"/>
+          </a:xfrm>
+          <a:prstGeom prst="rect">
+            <a:avLst/>
+          </a:prstGeom>
+          <a:noFill/>
+          <a:ln/>
+        </p:spPr>
+        <p:txBody>
+          <a:bodyPr wrap="square" lIns="0" tIns="0" rIns="0" bIns="0" rtlCol="0" anchor="ctr"/>
+          <a:lstStyle/>
+          <a:p>
+            <a:pPr algn="ctr" indent="0" marL="0">
+              <a:buNone/>
+            </a:pPr>
+            <a:r>
+              <a:rPr lang="en-US" sz="1200" b="1" dirty="0">
+                <a:solidFill>
+                  <a:srgbClr val="FFFFFF"/>
+                </a:solidFill>
+              </a:rPr>
+              <a:t>2</a:t>
+            </a:r>
+            <a:endParaRPr lang="en-US" sz="1200" dirty="0"/>
+          </a:p>
+        </p:txBody>
+      </p:sp>
+      <p:sp>
+        <p:nvSpPr>
+          <p:cNvPr id="10" name="Text 7"/>
+          <p:cNvSpPr txBox="1"/>
+          <p:nvPr/>
+        </p:nvSpPr>
+        <p:spPr>
+          <a:xfrm>
+            <a:off x="6537960" y="1188720"/>
+            <a:ext cx="5074920" cy="310896"/>
+          </a:xfrm>
+          <a:prstGeom prst="rect">
+            <a:avLst/>
+          </a:prstGeom>
+          <a:noFill/>
+          <a:ln/>
+        </p:spPr>
+        <p:txBody>
+          <a:bodyPr wrap="square" lIns="0" tIns="0" rIns="0" bIns="0" rtlCol="0" anchor="ctr"/>
+          <a:lstStyle/>
+          <a:p>
+            <a:pPr indent="0" marL="0">
+              <a:buNone/>
+            </a:pPr>
+            <a:r>
+              <a:rPr lang="en-US" sz="1300" b="1" dirty="0">
+                <a:solidFill>
+                  <a:srgbClr val="E2E8F0"/>
+                </a:solidFill>
+              </a:rPr>
+              <a:t>Critic rejects the planted claim, citing the real abstract (16/17 kept)</a:t>
+            </a:r>
+            <a:endParaRPr lang="en-US" sz="1300" dirty="0"/>
+          </a:p>
+        </p:txBody>
+      </p:sp>
+      <p:sp>
+        <p:nvSpPr>
+          <p:cNvPr id="11" name="panel 2 frame"/>
+          <p:cNvSpPr/>
+          <p:nvPr/>
+        </p:nvSpPr>
+        <p:spPr>
+          <a:xfrm>
+            <a:off x="6172200" y="1517904"/>
+            <a:ext cx="5440680" cy="1965960"/>
+          </a:xfrm>
+          <a:prstGeom prst="rect">
+            <a:avLst/>
+          </a:prstGeom>
+          <a:solidFill>
+            <a:srgbClr val="0E1117"/>
+          </a:solidFill>
+          <a:ln w="12700">
+            <a:solidFill>
+              <a:srgbClr val="334155"/>
+            </a:solidFill>
+            <a:prstDash val="solid"/>
+          </a:ln>
+        </p:spPr>
+      </p:sp>
       <p:pic>
         <p:nvPicPr>
-          <p:cNvPr id="8" name="planner icon" descr="preencoded.png">    </p:cNvPr>
+          <p:cNvPr id="12" name="panel 2 screenshot" descr="C:\Users\Adila\OneDrive\Documents\University\Adil\Intelligent Agents\scholarplan\presentation\assets\demo_2_critic.png">    </p:cNvPr>
           <p:cNvPicPr>
             <a:picLocks noChangeAspect="1"/>
           </p:cNvPicPr>
@@ -11939,8 +12071,8 @@
         </p:blipFill>
         <p:spPr>
           <a:xfrm>
-            <a:off x="7987467" y="1934139"/>
-            <a:ext cx="228234" cy="228234"/>
+            <a:off x="6227064" y="1633055"/>
+            <a:ext cx="5330952" cy="1735659"/>
           </a:xfrm>
           <a:prstGeom prst="rect">
             <a:avLst/>
@@ -11949,68 +12081,129 @@
       </p:pic>
       <p:sp>
         <p:nvSpPr>
-          <p:cNvPr id="9" name="Text 5"/>
-          <p:cNvSpPr txBox="1"/>
-          <p:nvPr/>
-        </p:nvSpPr>
-        <p:spPr>
-          <a:xfrm>
-            <a:off x="8458200" y="1773936"/>
-            <a:ext cx="3200400" cy="566928"/>
-          </a:xfrm>
-          <a:prstGeom prst="rect">
-            <a:avLst/>
-          </a:prstGeom>
-          <a:noFill/>
-          <a:ln/>
-        </p:spPr>
-        <p:txBody>
-          <a:bodyPr wrap="square" lIns="0" tIns="0" rIns="0" bIns="0" rtlCol="0" anchor="ctr"/>
-          <a:lstStyle/>
-          <a:p>
-            <a:pPr indent="0" marL="0">
-              <a:buNone/>
-            </a:pPr>
-            <a:r>
-              <a:rPr lang="en-US" sz="1400" dirty="0">
-                <a:solidFill>
-                  <a:srgbClr val="E2E8F0"/>
-                </a:solidFill>
-              </a:rPr>
-              <a:t>Planner Thought → 4-subtask plan</a:t>
-            </a:r>
-            <a:endParaRPr lang="en-US" sz="1400" dirty="0"/>
-          </a:p>
-        </p:txBody>
-      </p:sp>
-      <p:sp>
-        <p:nvSpPr>
-          <p:cNvPr id="10" name="retriever dot"/>
-          <p:cNvSpPr/>
-          <p:nvPr/>
-        </p:nvSpPr>
-        <p:spPr>
-          <a:xfrm>
-            <a:off x="7863840" y="2523744"/>
-            <a:ext cx="475488" cy="475488"/>
+          <p:cNvPr id="13" name="Shape 9"/>
+          <p:cNvSpPr/>
+          <p:nvPr/>
+        </p:nvSpPr>
+        <p:spPr>
+          <a:xfrm>
+            <a:off x="548640" y="3630168"/>
+            <a:ext cx="274320" cy="274320"/>
           </a:xfrm>
           <a:prstGeom prst="ellipse">
             <a:avLst/>
           </a:prstGeom>
           <a:solidFill>
-            <a:srgbClr val="16A34A"/>
+            <a:srgbClr val="9333EA"/>
           </a:solidFill>
           <a:ln w="12700">
             <a:solidFill>
-              <a:srgbClr val="16A34A"/>
+              <a:srgbClr val="9333EA"/>
             </a:solidFill>
             <a:prstDash val="solid"/>
           </a:ln>
         </p:spPr>
       </p:sp>
+      <p:sp>
+        <p:nvSpPr>
+          <p:cNvPr id="14" name="Text 10"/>
+          <p:cNvSpPr txBox="1"/>
+          <p:nvPr/>
+        </p:nvSpPr>
+        <p:spPr>
+          <a:xfrm>
+            <a:off x="548640" y="3630168"/>
+            <a:ext cx="274320" cy="274320"/>
+          </a:xfrm>
+          <a:prstGeom prst="rect">
+            <a:avLst/>
+          </a:prstGeom>
+          <a:noFill/>
+          <a:ln/>
+        </p:spPr>
+        <p:txBody>
+          <a:bodyPr wrap="square" lIns="0" tIns="0" rIns="0" bIns="0" rtlCol="0" anchor="ctr"/>
+          <a:lstStyle/>
+          <a:p>
+            <a:pPr algn="ctr" indent="0" marL="0">
+              <a:buNone/>
+            </a:pPr>
+            <a:r>
+              <a:rPr lang="en-US" sz="1200" b="1" dirty="0">
+                <a:solidFill>
+                  <a:srgbClr val="FFFFFF"/>
+                </a:solidFill>
+              </a:rPr>
+              <a:t>3</a:t>
+            </a:r>
+            <a:endParaRPr lang="en-US" sz="1200" dirty="0"/>
+          </a:p>
+        </p:txBody>
+      </p:sp>
+      <p:sp>
+        <p:nvSpPr>
+          <p:cNvPr id="15" name="Text 11"/>
+          <p:cNvSpPr txBox="1"/>
+          <p:nvPr/>
+        </p:nvSpPr>
+        <p:spPr>
+          <a:xfrm>
+            <a:off x="914400" y="3611880"/>
+            <a:ext cx="5074920" cy="310896"/>
+          </a:xfrm>
+          <a:prstGeom prst="rect">
+            <a:avLst/>
+          </a:prstGeom>
+          <a:noFill/>
+          <a:ln/>
+        </p:spPr>
+        <p:txBody>
+          <a:bodyPr wrap="square" lIns="0" tIns="0" rIns="0" bIns="0" rtlCol="0" anchor="ctr"/>
+          <a:lstStyle/>
+          <a:p>
+            <a:pPr indent="0" marL="0">
+              <a:buNone/>
+            </a:pPr>
+            <a:r>
+              <a:rPr lang="en-US" sz="1300" b="1" dirty="0">
+                <a:solidFill>
+                  <a:srgbClr val="E2E8F0"/>
+                </a:solidFill>
+              </a:rPr>
+              <a:t>Feedback drives re-planning: 2 re-plans, then 4/4 verified (earlier live run)</a:t>
+            </a:r>
+            <a:endParaRPr lang="en-US" sz="1300" dirty="0"/>
+          </a:p>
+        </p:txBody>
+      </p:sp>
+      <p:sp>
+        <p:nvSpPr>
+          <p:cNvPr id="16" name="panel 3 frame"/>
+          <p:cNvSpPr/>
+          <p:nvPr/>
+        </p:nvSpPr>
+        <p:spPr>
+          <a:xfrm>
+            <a:off x="548640" y="3941064"/>
+            <a:ext cx="5440680" cy="1965960"/>
+          </a:xfrm>
+          <a:prstGeom prst="rect">
+            <a:avLst/>
+          </a:prstGeom>
+          <a:solidFill>
+            <a:srgbClr val="0E1117"/>
+          </a:solidFill>
+          <a:ln w="12700">
+            <a:solidFill>
+              <a:srgbClr val="334155"/>
+            </a:solidFill>
+            <a:prstDash val="solid"/>
+          </a:ln>
+        </p:spPr>
+      </p:sp>
       <p:pic>
         <p:nvPicPr>
-          <p:cNvPr id="11" name="retriever icon" descr="preencoded.png">    </p:cNvPr>
+          <p:cNvPr id="17" name="panel 3 screenshot" descr="C:\Users\Adila\OneDrive\Documents\University\Adil\Intelligent Agents\scholarplan\presentation\assets\demo_3_replan.png">    </p:cNvPr>
           <p:cNvPicPr>
             <a:picLocks noChangeAspect="1"/>
           </p:cNvPicPr>
@@ -12024,8 +12217,8 @@
         </p:blipFill>
         <p:spPr>
           <a:xfrm>
-            <a:off x="7987467" y="2647371"/>
-            <a:ext cx="228234" cy="228234"/>
+            <a:off x="603504" y="4164693"/>
+            <a:ext cx="5330952" cy="1518701"/>
           </a:xfrm>
           <a:prstGeom prst="rect">
             <a:avLst/>
@@ -12034,68 +12227,129 @@
       </p:pic>
       <p:sp>
         <p:nvSpPr>
-          <p:cNvPr id="12" name="Text 7"/>
-          <p:cNvSpPr txBox="1"/>
-          <p:nvPr/>
-        </p:nvSpPr>
-        <p:spPr>
-          <a:xfrm>
-            <a:off x="8458200" y="2487168"/>
-            <a:ext cx="3200400" cy="566928"/>
-          </a:xfrm>
-          <a:prstGeom prst="rect">
-            <a:avLst/>
-          </a:prstGeom>
-          <a:noFill/>
-          <a:ln/>
-        </p:spPr>
-        <p:txBody>
-          <a:bodyPr wrap="square" lIns="0" tIns="0" rIns="0" bIns="0" rtlCol="0" anchor="ctr"/>
-          <a:lstStyle/>
-          <a:p>
-            <a:pPr indent="0" marL="0">
-              <a:buNone/>
-            </a:pPr>
-            <a:r>
-              <a:rPr lang="en-US" sz="1400" dirty="0">
-                <a:solidFill>
-                  <a:srgbClr val="E2E8F0"/>
-                </a:solidFill>
-              </a:rPr>
-              <a:t>Highlighted card = agent acting; per-API record counts</a:t>
-            </a:r>
-            <a:endParaRPr lang="en-US" sz="1400" dirty="0"/>
-          </a:p>
-        </p:txBody>
-      </p:sp>
-      <p:sp>
-        <p:nvSpPr>
-          <p:cNvPr id="13" name="processor dot"/>
-          <p:cNvSpPr/>
-          <p:nvPr/>
-        </p:nvSpPr>
-        <p:spPr>
-          <a:xfrm>
-            <a:off x="7863840" y="3236976"/>
-            <a:ext cx="475488" cy="475488"/>
+          <p:cNvPr id="18" name="Shape 13"/>
+          <p:cNvSpPr/>
+          <p:nvPr/>
+        </p:nvSpPr>
+        <p:spPr>
+          <a:xfrm>
+            <a:off x="6172200" y="3630168"/>
+            <a:ext cx="274320" cy="274320"/>
           </a:xfrm>
           <a:prstGeom prst="ellipse">
             <a:avLst/>
           </a:prstGeom>
           <a:solidFill>
-            <a:srgbClr val="9333EA"/>
+            <a:srgbClr val="DC2626"/>
           </a:solidFill>
           <a:ln w="12700">
             <a:solidFill>
-              <a:srgbClr val="9333EA"/>
+              <a:srgbClr val="DC2626"/>
             </a:solidFill>
             <a:prstDash val="solid"/>
           </a:ln>
         </p:spPr>
       </p:sp>
+      <p:sp>
+        <p:nvSpPr>
+          <p:cNvPr id="19" name="Text 14"/>
+          <p:cNvSpPr txBox="1"/>
+          <p:nvPr/>
+        </p:nvSpPr>
+        <p:spPr>
+          <a:xfrm>
+            <a:off x="6172200" y="3630168"/>
+            <a:ext cx="274320" cy="274320"/>
+          </a:xfrm>
+          <a:prstGeom prst="rect">
+            <a:avLst/>
+          </a:prstGeom>
+          <a:noFill/>
+          <a:ln/>
+        </p:spPr>
+        <p:txBody>
+          <a:bodyPr wrap="square" lIns="0" tIns="0" rIns="0" bIns="0" rtlCol="0" anchor="ctr"/>
+          <a:lstStyle/>
+          <a:p>
+            <a:pPr algn="ctr" indent="0" marL="0">
+              <a:buNone/>
+            </a:pPr>
+            <a:r>
+              <a:rPr lang="en-US" sz="1200" b="1" dirty="0">
+                <a:solidFill>
+                  <a:srgbClr val="FFFFFF"/>
+                </a:solidFill>
+              </a:rPr>
+              <a:t>4</a:t>
+            </a:r>
+            <a:endParaRPr lang="en-US" sz="1200" dirty="0"/>
+          </a:p>
+        </p:txBody>
+      </p:sp>
+      <p:sp>
+        <p:nvSpPr>
+          <p:cNvPr id="20" name="Text 15"/>
+          <p:cNvSpPr txBox="1"/>
+          <p:nvPr/>
+        </p:nvSpPr>
+        <p:spPr>
+          <a:xfrm>
+            <a:off x="6537960" y="3611880"/>
+            <a:ext cx="5074920" cy="310896"/>
+          </a:xfrm>
+          <a:prstGeom prst="rect">
+            <a:avLst/>
+          </a:prstGeom>
+          <a:noFill/>
+          <a:ln/>
+        </p:spPr>
+        <p:txBody>
+          <a:bodyPr wrap="square" lIns="0" tIns="0" rIns="0" bIns="0" rtlCol="0" anchor="ctr"/>
+          <a:lstStyle/>
+          <a:p>
+            <a:pPr indent="0" marL="0">
+              <a:buNone/>
+            </a:pPr>
+            <a:r>
+              <a:rPr lang="en-US" sz="1300" b="1" dirty="0">
+                <a:solidFill>
+                  <a:srgbClr val="E2E8F0"/>
+                </a:solidFill>
+              </a:rPr>
+              <a:t>Verified report: Harvard citations keep claim IDs; BibTeX and trace saved</a:t>
+            </a:r>
+            <a:endParaRPr lang="en-US" sz="1300" dirty="0"/>
+          </a:p>
+        </p:txBody>
+      </p:sp>
+      <p:sp>
+        <p:nvSpPr>
+          <p:cNvPr id="21" name="panel 4 frame"/>
+          <p:cNvSpPr/>
+          <p:nvPr/>
+        </p:nvSpPr>
+        <p:spPr>
+          <a:xfrm>
+            <a:off x="6172200" y="3941064"/>
+            <a:ext cx="5440680" cy="1965960"/>
+          </a:xfrm>
+          <a:prstGeom prst="rect">
+            <a:avLst/>
+          </a:prstGeom>
+          <a:solidFill>
+            <a:srgbClr val="0E1117"/>
+          </a:solidFill>
+          <a:ln w="12700">
+            <a:solidFill>
+              <a:srgbClr val="334155"/>
+            </a:solidFill>
+            <a:prstDash val="solid"/>
+          </a:ln>
+        </p:spPr>
+      </p:sp>
       <p:pic>
         <p:nvPicPr>
-          <p:cNvPr id="14" name="processor icon" descr="preencoded.png">    </p:cNvPr>
+          <p:cNvPr id="22" name="panel 4 screenshot" descr="C:\Users\Adila\OneDrive\Documents\University\Adil\Intelligent Agents\scholarplan\presentation\assets\demo_4_report.png">    </p:cNvPr>
           <p:cNvPicPr>
             <a:picLocks noChangeAspect="1"/>
           </p:cNvPicPr>
@@ -12109,8 +12363,8 @@
         </p:blipFill>
         <p:spPr>
           <a:xfrm>
-            <a:off x="7987467" y="3360603"/>
-            <a:ext cx="228234" cy="228234"/>
+            <a:off x="6227064" y="4214842"/>
+            <a:ext cx="5330952" cy="1418404"/>
           </a:xfrm>
           <a:prstGeom prst="rect">
             <a:avLst/>
@@ -12119,99 +12373,41 @@
       </p:pic>
       <p:sp>
         <p:nvSpPr>
-          <p:cNvPr id="15" name="Text 9"/>
-          <p:cNvSpPr txBox="1"/>
-          <p:nvPr/>
-        </p:nvSpPr>
-        <p:spPr>
-          <a:xfrm>
-            <a:off x="8458200" y="3200400"/>
-            <a:ext cx="3200400" cy="566928"/>
-          </a:xfrm>
-          <a:prstGeom prst="rect">
-            <a:avLst/>
-          </a:prstGeom>
-          <a:noFill/>
-          <a:ln/>
-        </p:spPr>
-        <p:txBody>
-          <a:bodyPr wrap="square" lIns="0" tIns="0" rIns="0" bIns="0" rtlCol="0" anchor="ctr"/>
-          <a:lstStyle/>
-          <a:p>
-            <a:pPr indent="0" marL="0">
-              <a:buNone/>
-            </a:pPr>
-            <a:r>
-              <a:rPr lang="en-US" sz="1400" dirty="0">
-                <a:solidFill>
-                  <a:srgbClr val="E2E8F0"/>
-                </a:solidFill>
-              </a:rPr>
-              <a:t>Duplicates removed · sources selected</a:t>
-            </a:r>
-            <a:endParaRPr lang="en-US" sz="1400" dirty="0"/>
-          </a:p>
-        </p:txBody>
-      </p:sp>
-      <p:sp>
-        <p:nvSpPr>
-          <p:cNvPr id="16" name="critic dot"/>
-          <p:cNvSpPr/>
-          <p:nvPr/>
-        </p:nvSpPr>
-        <p:spPr>
-          <a:xfrm>
-            <a:off x="7863840" y="3950208"/>
-            <a:ext cx="475488" cy="475488"/>
-          </a:xfrm>
-          <a:prstGeom prst="ellipse">
-            <a:avLst/>
-          </a:prstGeom>
-          <a:solidFill>
-            <a:srgbClr val="EA580C"/>
+          <p:cNvPr id="23" name="Shape 17"/>
+          <p:cNvSpPr/>
+          <p:nvPr/>
+        </p:nvSpPr>
+        <p:spPr>
+          <a:xfrm>
+            <a:off x="548640" y="5998464"/>
+            <a:ext cx="11064240" cy="384048"/>
+          </a:xfrm>
+          <a:prstGeom prst="roundRect">
+            <a:avLst>
+              <a:gd name="adj" fmla="val 14286"/>
+            </a:avLst>
+          </a:prstGeom>
+          <a:solidFill>
+            <a:srgbClr val="1E293B"/>
           </a:solidFill>
           <a:ln w="12700">
             <a:solidFill>
-              <a:srgbClr val="EA580C"/>
+              <a:srgbClr val="334155"/>
             </a:solidFill>
             <a:prstDash val="solid"/>
           </a:ln>
         </p:spPr>
       </p:sp>
-      <p:pic>
-        <p:nvPicPr>
-          <p:cNvPr id="17" name="critic icon" descr="preencoded.png">    </p:cNvPr>
-          <p:cNvPicPr>
-            <a:picLocks noChangeAspect="1"/>
-          </p:cNvPicPr>
-          <p:nvPr/>
-        </p:nvPicPr>
-        <p:blipFill>
-          <a:blip r:embed="rId5"/>
-          <a:stretch>
-            <a:fillRect/>
-          </a:stretch>
-        </p:blipFill>
-        <p:spPr>
-          <a:xfrm>
-            <a:off x="7987467" y="4073835"/>
-            <a:ext cx="228234" cy="228234"/>
-          </a:xfrm>
-          <a:prstGeom prst="rect">
-            <a:avLst/>
-          </a:prstGeom>
-        </p:spPr>
-      </p:pic>
-      <p:sp>
-        <p:nvSpPr>
-          <p:cNvPr id="18" name="Text 11"/>
-          <p:cNvSpPr txBox="1"/>
-          <p:nvPr/>
-        </p:nvSpPr>
-        <p:spPr>
-          <a:xfrm>
-            <a:off x="8458200" y="3913632"/>
-            <a:ext cx="3200400" cy="566928"/>
+      <p:sp>
+        <p:nvSpPr>
+          <p:cNvPr id="24" name="Text 18"/>
+          <p:cNvSpPr txBox="1"/>
+          <p:nvPr/>
+        </p:nvSpPr>
+        <p:spPr>
+          <a:xfrm>
+            <a:off x="685800" y="5998464"/>
+            <a:ext cx="10835640" cy="384048"/>
           </a:xfrm>
           <a:prstGeom prst="rect">
             <a:avLst/>
@@ -12227,165 +12423,43 @@
               <a:buNone/>
             </a:pPr>
             <a:r>
-              <a:rPr lang="en-US" sz="1400" dirty="0">
-                <a:solidFill>
-                  <a:srgbClr val="E2E8F0"/>
-                </a:solidFill>
-              </a:rPr>
-              <a:t>Planted [DEMO] claim rejected, with reason + abstract</a:t>
-            </a:r>
-            <a:endParaRPr lang="en-US" sz="1400" dirty="0"/>
-          </a:p>
-        </p:txBody>
-      </p:sp>
-      <p:sp>
-        <p:nvSpPr>
-          <p:cNvPr id="19" name="archivist dot"/>
-          <p:cNvSpPr/>
-          <p:nvPr/>
-        </p:nvSpPr>
-        <p:spPr>
-          <a:xfrm>
-            <a:off x="7863840" y="4663440"/>
-            <a:ext cx="475488" cy="475488"/>
-          </a:xfrm>
-          <a:prstGeom prst="ellipse">
-            <a:avLst/>
-          </a:prstGeom>
-          <a:solidFill>
-            <a:srgbClr val="DC2626"/>
-          </a:solidFill>
-          <a:ln w="12700">
-            <a:solidFill>
-              <a:srgbClr val="DC2626"/>
-            </a:solidFill>
-            <a:prstDash val="solid"/>
-          </a:ln>
-        </p:spPr>
-      </p:sp>
-      <p:pic>
-        <p:nvPicPr>
-          <p:cNvPr id="20" name="archivist icon" descr="preencoded.png">    </p:cNvPr>
-          <p:cNvPicPr>
-            <a:picLocks noChangeAspect="1"/>
-          </p:cNvPicPr>
-          <p:nvPr/>
-        </p:nvPicPr>
-        <p:blipFill>
-          <a:blip r:embed="rId6"/>
-          <a:stretch>
-            <a:fillRect/>
-          </a:stretch>
-        </p:blipFill>
-        <p:spPr>
-          <a:xfrm>
-            <a:off x="7987467" y="4787067"/>
-            <a:ext cx="228234" cy="228234"/>
-          </a:xfrm>
-          <a:prstGeom prst="rect">
-            <a:avLst/>
-          </a:prstGeom>
-        </p:spPr>
-      </p:pic>
-      <p:sp>
-        <p:nvSpPr>
-          <p:cNvPr id="21" name="Text 13"/>
-          <p:cNvSpPr txBox="1"/>
-          <p:nvPr/>
-        </p:nvSpPr>
-        <p:spPr>
-          <a:xfrm>
-            <a:off x="8458200" y="4626864"/>
-            <a:ext cx="3200400" cy="566928"/>
-          </a:xfrm>
-          <a:prstGeom prst="rect">
-            <a:avLst/>
-          </a:prstGeom>
-          <a:noFill/>
-          <a:ln/>
-        </p:spPr>
-        <p:txBody>
-          <a:bodyPr wrap="square" lIns="0" tIns="0" rIns="0" bIns="0" rtlCol="0" anchor="ctr"/>
-          <a:lstStyle/>
-          <a:p>
+              <a:rPr lang="en-US" sz="1100" b="1" dirty="0">
+                <a:solidFill>
+                  <a:srgbClr val="F2A541"/>
+                </a:solidFill>
+              </a:rPr>
+              <a:t>All evidence → </a:t>
+            </a:r>
             <a:pPr indent="0" marL="0">
               <a:buNone/>
             </a:pPr>
             <a:r>
-              <a:rPr lang="en-US" sz="1400" dirty="0">
-                <a:solidFill>
-                  <a:srgbClr val="E2E8F0"/>
-                </a:solidFill>
-              </a:rPr>
-              <a:t>Report · BibTeX · semantic search of the index</a:t>
-            </a:r>
-            <a:endParaRPr lang="en-US" sz="1400" dirty="0"/>
-          </a:p>
-        </p:txBody>
-      </p:sp>
-      <p:sp>
-        <p:nvSpPr>
-          <p:cNvPr id="22" name="Shape 14"/>
-          <p:cNvSpPr/>
-          <p:nvPr/>
-        </p:nvSpPr>
-        <p:spPr>
-          <a:xfrm>
-            <a:off x="7863840" y="5440680"/>
-            <a:ext cx="3794760" cy="566928"/>
-          </a:xfrm>
-          <a:prstGeom prst="roundRect">
-            <a:avLst>
-              <a:gd name="adj" fmla="val 12903"/>
-            </a:avLst>
-          </a:prstGeom>
-          <a:solidFill>
-            <a:srgbClr val="1E293B"/>
-          </a:solidFill>
-          <a:ln w="12700">
-            <a:solidFill>
-              <a:srgbClr val="475569"/>
-            </a:solidFill>
-            <a:prstDash val="solid"/>
-          </a:ln>
-        </p:spPr>
-      </p:sp>
-      <p:sp>
-        <p:nvSpPr>
-          <p:cNvPr id="23" name="Text 15"/>
-          <p:cNvSpPr txBox="1"/>
-          <p:nvPr/>
-        </p:nvSpPr>
-        <p:spPr>
-          <a:xfrm>
-            <a:off x="7973568" y="5458968"/>
-            <a:ext cx="3611880" cy="530352"/>
-          </a:xfrm>
-          <a:prstGeom prst="rect">
-            <a:avLst/>
-          </a:prstGeom>
-          <a:noFill/>
-          <a:ln/>
-        </p:spPr>
-        <p:txBody>
-          <a:bodyPr wrap="square" lIns="0" tIns="0" rIns="0" bIns="0" rtlCol="0" anchor="ctr"/>
-          <a:lstStyle/>
-          <a:p>
+              <a:rPr lang="en-US" sz="1100" b="1" u="sng" dirty="0">
+                <a:solidFill>
+                  <a:srgbClr val="FFFFFF"/>
+                </a:solidFill>
+                <a:hlinkClick r:id="rId5" invalidUrl="" action="" tgtFrame="" tooltip="" history="1" highlightClick="0" endSnd="0">
+                  <a:extLst>
+                    <a:ext uri="{A12FA001-AC4F-418D-AE19-62706E023703}">
+                      <ahyp:hlinkClr xmlns:ahyp="http://schemas.microsoft.com/office/drawing/2018/hyperlinkcolor" val="tx"/>
+                    </a:ext>
+                  </a:extLst>
+                </a:hlinkClick>
+              </a:rPr>
+              <a:t>github.com/adilaljasmi/scholarplan</a:t>
+            </a:r>
             <a:pPr indent="0" marL="0">
               <a:buNone/>
             </a:pPr>
             <a:r>
-              <a:rPr lang="en-US" sz="1200" dirty="0">
+              <a:rPr lang="en-US" sz="1100" dirty="0">
                 <a:solidFill>
                   <a:srgbClr val="CBD5E1"/>
                 </a:solidFill>
-                <a:latin typeface="Calibri" pitchFamily="34" charset="0"/>
-                <a:ea typeface="Calibri" pitchFamily="34" charset="-122"/>
-                <a:cs typeface="Calibri" pitchFamily="34" charset="-120"/>
-              </a:rPr>
-              <a:t>Code: planner._react_step · _validate · blackboard.claim_subtask</a:t>
-            </a:r>
-            <a:endParaRPr lang="en-US" sz="1200" dirty="0"/>
+              </a:rPr>
+              <a:t>  ·  evidence/runs  ·  evidence/screenshots  ·  evidence/tests  ·  evidence/evaluation  ·  docs/REMEDIATION_LOG.md</a:t>
+            </a:r>
+            <a:endParaRPr lang="en-US" sz="1100" dirty="0"/>
           </a:p>
         </p:txBody>
       </p:sp>
@@ -12720,7 +12794,7 @@
                   <a:schemeClr val="tx2"/>
                 </a:solidFill>
               </a:rPr>
-              <a:t>10 fixed queries for papers our Unit 6 report cited; arXiv 7 · OpenAlex 6 · Crossref 1. Miss: Hayes-Roth (1985), no indexed abstract.</a:t>
+              <a:t>10 fixed queries for papers our Unit 6 report cited; arXiv 8 · OpenAlex 6 · Crossref 1. Miss: Hayes-Roth (1985), no indexed abstract.</a:t>
             </a:r>
             <a:endParaRPr lang="en-US" sz="1100" dirty="0"/>
           </a:p>
@@ -13209,7 +13283,7 @@
                 <a:ea typeface="Cambria" pitchFamily="34" charset="-122"/>
                 <a:cs typeface="Cambria" pitchFamily="34" charset="-120"/>
               </a:rPr>
-              <a:t>94</a:t>
+              <a:t>96</a:t>
             </a:r>
             <a:endParaRPr lang="en-US" sz="3000" dirty="0"/>
           </a:p>
@@ -13311,7 +13385,7 @@
                 <a:ea typeface="Cambria" pitchFamily="34" charset="-122"/>
                 <a:cs typeface="Cambria" pitchFamily="34" charset="-120"/>
               </a:rPr>
-              <a:t>93%</a:t>
+              <a:t>92%</a:t>
             </a:r>
             <a:endParaRPr lang="en-US" sz="3000" dirty="0"/>
           </a:p>
@@ -13515,7 +13589,7 @@
                 <a:ea typeface="Cambria" pitchFamily="34" charset="-122"/>
                 <a:cs typeface="Cambria" pitchFamily="34" charset="-120"/>
               </a:rPr>
-              <a:t>19</a:t>
+              <a:t>20</a:t>
             </a:r>
             <a:endParaRPr lang="en-US" sz="3000" dirty="0"/>
           </a:p>
@@ -13795,7 +13869,7 @@
                   <a:srgbClr val="FFFFFF"/>
                 </a:solidFill>
               </a:rPr>
-              <a:t>Unit (82)</a:t>
+              <a:t>Unit (84)</a:t>
             </a:r>
             <a:endParaRPr lang="en-US" sz="1200" dirty="0"/>
           </a:p>
@@ -14409,8 +14483,8 @@
         </p:nvSpPr>
         <p:spPr>
           <a:xfrm>
-            <a:off x="4114800" y="5577840"/>
-            <a:ext cx="914400" cy="457200"/>
+            <a:off x="4151376" y="5577840"/>
+            <a:ext cx="841248" cy="457200"/>
           </a:xfrm>
           <a:prstGeom prst="rect">
             <a:avLst/>
@@ -14445,7 +14519,7 @@
         </p:nvSpPr>
         <p:spPr>
           <a:xfrm>
-            <a:off x="5482481" y="5358384"/>
+            <a:off x="5358384" y="5358384"/>
             <a:ext cx="164592" cy="164592"/>
           </a:xfrm>
           <a:prstGeom prst="ellipse">
@@ -14470,8 +14544,8 @@
         </p:nvSpPr>
         <p:spPr>
           <a:xfrm>
-            <a:off x="5107577" y="5577840"/>
-            <a:ext cx="914400" cy="457200"/>
+            <a:off x="5020056" y="5577840"/>
+            <a:ext cx="841248" cy="457200"/>
           </a:xfrm>
           <a:prstGeom prst="rect">
             <a:avLst/>
@@ -14506,7 +14580,7 @@
         </p:nvSpPr>
         <p:spPr>
           <a:xfrm>
-            <a:off x="6475258" y="5358384"/>
+            <a:off x="6227064" y="5358384"/>
             <a:ext cx="164592" cy="164592"/>
           </a:xfrm>
           <a:prstGeom prst="ellipse">
@@ -14531,8 +14605,8 @@
         </p:nvSpPr>
         <p:spPr>
           <a:xfrm>
-            <a:off x="6100354" y="5577840"/>
-            <a:ext cx="914400" cy="457200"/>
+            <a:off x="5888736" y="5577840"/>
+            <a:ext cx="841248" cy="457200"/>
           </a:xfrm>
           <a:prstGeom prst="rect">
             <a:avLst/>
@@ -14567,7 +14641,7 @@
         </p:nvSpPr>
         <p:spPr>
           <a:xfrm>
-            <a:off x="7468035" y="5358384"/>
+            <a:off x="7095744" y="5358384"/>
             <a:ext cx="164592" cy="164592"/>
           </a:xfrm>
           <a:prstGeom prst="ellipse">
@@ -14592,8 +14666,8 @@
         </p:nvSpPr>
         <p:spPr>
           <a:xfrm>
-            <a:off x="7093131" y="5577840"/>
-            <a:ext cx="914400" cy="457200"/>
+            <a:off x="6757416" y="5577840"/>
+            <a:ext cx="841248" cy="457200"/>
           </a:xfrm>
           <a:prstGeom prst="rect">
             <a:avLst/>
@@ -14628,7 +14702,7 @@
         </p:nvSpPr>
         <p:spPr>
           <a:xfrm>
-            <a:off x="8460813" y="5358384"/>
+            <a:off x="7964424" y="5358384"/>
             <a:ext cx="164592" cy="164592"/>
           </a:xfrm>
           <a:prstGeom prst="ellipse">
@@ -14653,8 +14727,8 @@
         </p:nvSpPr>
         <p:spPr>
           <a:xfrm>
-            <a:off x="8085909" y="5577840"/>
-            <a:ext cx="914400" cy="457200"/>
+            <a:off x="7626096" y="5577840"/>
+            <a:ext cx="841248" cy="457200"/>
           </a:xfrm>
           <a:prstGeom prst="rect">
             <a:avLst/>
@@ -14689,7 +14763,7 @@
         </p:nvSpPr>
         <p:spPr>
           <a:xfrm>
-            <a:off x="9453590" y="5358384"/>
+            <a:off x="8833104" y="5358384"/>
             <a:ext cx="164592" cy="164592"/>
           </a:xfrm>
           <a:prstGeom prst="ellipse">
@@ -14714,8 +14788,8 @@
         </p:nvSpPr>
         <p:spPr>
           <a:xfrm>
-            <a:off x="9078686" y="5577840"/>
-            <a:ext cx="914400" cy="457200"/>
+            <a:off x="8494776" y="5577840"/>
+            <a:ext cx="841248" cy="457200"/>
           </a:xfrm>
           <a:prstGeom prst="rect">
             <a:avLst/>
@@ -14750,7 +14824,7 @@
         </p:nvSpPr>
         <p:spPr>
           <a:xfrm>
-            <a:off x="10446367" y="5358384"/>
+            <a:off x="9701784" y="5358384"/>
             <a:ext cx="164592" cy="164592"/>
           </a:xfrm>
           <a:prstGeom prst="ellipse">
@@ -14775,8 +14849,8 @@
         </p:nvSpPr>
         <p:spPr>
           <a:xfrm>
-            <a:off x="10071463" y="5577840"/>
-            <a:ext cx="914400" cy="457200"/>
+            <a:off x="9363456" y="5577840"/>
+            <a:ext cx="841248" cy="457200"/>
           </a:xfrm>
           <a:prstGeom prst="rect">
             <a:avLst/>
@@ -14806,6 +14880,67 @@
       <p:sp>
         <p:nvSpPr>
           <p:cNvPr id="56" name="Shape 51"/>
+          <p:cNvSpPr/>
+          <p:nvPr/>
+        </p:nvSpPr>
+        <p:spPr>
+          <a:xfrm>
+            <a:off x="10570464" y="5358384"/>
+            <a:ext cx="164592" cy="164592"/>
+          </a:xfrm>
+          <a:prstGeom prst="ellipse">
+            <a:avLst/>
+          </a:prstGeom>
+          <a:solidFill>
+            <a:srgbClr val="0E7C7B"/>
+          </a:solidFill>
+          <a:ln w="12700">
+            <a:solidFill>
+              <a:srgbClr val="FFFFFF"/>
+            </a:solidFill>
+            <a:prstDash val="solid"/>
+          </a:ln>
+        </p:spPr>
+      </p:sp>
+      <p:sp>
+        <p:nvSpPr>
+          <p:cNvPr id="57" name="Text 52"/>
+          <p:cNvSpPr txBox="1"/>
+          <p:nvPr/>
+        </p:nvSpPr>
+        <p:spPr>
+          <a:xfrm>
+            <a:off x="10232136" y="5577840"/>
+            <a:ext cx="841248" cy="457200"/>
+          </a:xfrm>
+          <a:prstGeom prst="rect">
+            <a:avLst/>
+          </a:prstGeom>
+          <a:noFill/>
+          <a:ln/>
+        </p:spPr>
+        <p:txBody>
+          <a:bodyPr wrap="square" lIns="0" tIns="0" rIns="0" bIns="0" rtlCol="0" anchor="t"/>
+          <a:lstStyle/>
+          <a:p>
+            <a:pPr algn="ctr" indent="0" marL="0">
+              <a:buNone/>
+            </a:pPr>
+            <a:r>
+              <a:rPr lang="en-US" sz="1000" dirty="0">
+                <a:solidFill>
+                  <a:schemeClr val="tx2"/>
+                </a:solidFill>
+              </a:rPr>
+              <a:t>README &amp; evidence</a:t>
+            </a:r>
+            <a:endParaRPr lang="en-US" sz="1000" dirty="0"/>
+          </a:p>
+        </p:txBody>
+      </p:sp>
+      <p:sp>
+        <p:nvSpPr>
+          <p:cNvPr id="58" name="Shape 53"/>
           <p:cNvSpPr/>
           <p:nvPr/>
         </p:nvSpPr>
@@ -14830,14 +14965,14 @@
       </p:sp>
       <p:sp>
         <p:nvSpPr>
-          <p:cNvPr id="57" name="Text 52"/>
-          <p:cNvSpPr txBox="1"/>
-          <p:nvPr/>
-        </p:nvSpPr>
-        <p:spPr>
-          <a:xfrm>
-            <a:off x="11064240" y="5577840"/>
-            <a:ext cx="914400" cy="457200"/>
+          <p:cNvPr id="59" name="Text 54"/>
+          <p:cNvSpPr txBox="1"/>
+          <p:nvPr/>
+        </p:nvSpPr>
+        <p:spPr>
+          <a:xfrm>
+            <a:off x="11100816" y="5577840"/>
+            <a:ext cx="841248" cy="457200"/>
           </a:xfrm>
           <a:prstGeom prst="rect">
             <a:avLst/>
@@ -14858,7 +14993,7 @@
                   <a:schemeClr val="tx2"/>
                 </a:solidFill>
               </a:rPr>
-              <a:t>README &amp; evidence</a:t>
+              <a:t>Presentation</a:t>
             </a:r>
             <a:endParaRPr lang="en-US" sz="1000" dirty="0"/>
           </a:p>

</xml_diff>

<commit_message>
Slide 10: full Harvard reference entries (italics, DOIs, access dates)
</commit_message>
<xml_diff>
--- a/presentation/ScholarPlan_Unit11_Presentation.pptx
+++ b/presentation/ScholarPlan_Unit11_Presentation.pptx
@@ -116,12 +116,12 @@
   <p:extLst>
     <p:ext uri="{521415D9-36F7-43E2-AB2F-B90AF26B5E84}">
       <p14:sectionLst xmlns:p14="http://schemas.microsoft.com/office/powerpoint/2010/main">
-        <p14:section name="Introduction" id="{66669020-028e-a083-65de-6c5c3fd54512}">
+        <p14:section name="Introduction" id="{8fd63d79-7560-70e6-e4a0-13efa93a65a8}">
           <p14:sldIdLst>
             <p14:sldId id="256"/>
           </p14:sldIdLst>
         </p14:section>
-        <p14:section name="System" id="{33a0cdd5-1c03-97b9-b8fa-7b33f671a03c}">
+        <p14:section name="System" id="{11adc8fa-7653-dfce-e5ed-a21488c7f266}">
           <p14:sldIdLst>
             <p14:sldId id="257"/>
             <p14:sldId id="258"/>
@@ -129,18 +129,18 @@
             <p14:sldId id="260"/>
           </p14:sldIdLst>
         </p14:section>
-        <p14:section name="Demonstration" id="{bb3d5ab5-9aee-235b-1e3e-7db59d536c64}">
+        <p14:section name="Demonstration" id="{64853719-35e5-898d-2672-ad7d7e94e7b8}">
           <p14:sldIdLst>
             <p14:sldId id="261"/>
           </p14:sldIdLst>
         </p14:section>
-        <p14:section name="Evidence" id="{e0ea083e-ae68-1e3a-d6ae-8a8f3507acbb}">
+        <p14:section name="Evidence" id="{69c74001-31fb-7308-2347-cbb0c129b78d}">
           <p14:sldIdLst>
             <p14:sldId id="262"/>
             <p14:sldId id="263"/>
           </p14:sldIdLst>
         </p14:section>
-        <p14:section name="Reflection" id="{c6df5d74-0534-f532-f927-e91ac627c98a}">
+        <p14:section name="Reflection" id="{d198c5ac-7bb3-7908-2d40-bed4709162c7}">
           <p14:sldIdLst>
             <p14:sldId id="264"/>
             <p14:sldId id="265"/>
@@ -3755,12 +3755,12 @@
         </p:nvSpPr>
         <p:spPr>
           <a:xfrm>
-            <a:off x="6309360" y="1234440"/>
-            <a:ext cx="5349240" cy="4206240"/>
+            <a:off x="6309360" y="1188720"/>
+            <a:ext cx="5349240" cy="4846320"/>
           </a:xfrm>
           <a:prstGeom prst="roundRect">
             <a:avLst>
-              <a:gd name="adj" fmla="val 1739"/>
+              <a:gd name="adj" fmla="val 1509"/>
             </a:avLst>
           </a:prstGeom>
           <a:solidFill>
@@ -3782,8 +3782,8 @@
         </p:nvSpPr>
         <p:spPr>
           <a:xfrm>
-            <a:off x="6492240" y="1325880"/>
-            <a:ext cx="5029200" cy="365760"/>
+            <a:off x="6492240" y="1261872"/>
+            <a:ext cx="5029200" cy="329184"/>
           </a:xfrm>
           <a:prstGeom prst="rect">
             <a:avLst/>
@@ -3818,8 +3818,8 @@
         </p:nvSpPr>
         <p:spPr>
           <a:xfrm>
-            <a:off x="6492240" y="1737360"/>
-            <a:ext cx="5029200" cy="3611880"/>
+            <a:off x="6492240" y="1627632"/>
+            <a:ext cx="5029200" cy="4343400"/>
           </a:xfrm>
           <a:prstGeom prst="rect">
             <a:avLst/>
@@ -3833,155 +3833,407 @@
           <a:p>
             <a:pPr indent="0" marL="0">
               <a:spcAft>
-                <a:spcPts val="400"/>
+                <a:spcPts val="500"/>
               </a:spcAft>
               <a:buNone/>
             </a:pPr>
             <a:r>
-              <a:rPr lang="en-US" sz="1050" dirty="0">
+              <a:rPr lang="en-US" sz="1000" dirty="0">
                 <a:solidFill>
                   <a:srgbClr val="CBD5E1"/>
                 </a:solidFill>
               </a:rPr>
-              <a:t>Guo, T. et al. (2024) 'Large language model based multi-agents: a survey of progress and challenges', IJCAI-24, pp. 8048–8057.</a:t>
-            </a:r>
-            <a:endParaRPr lang="en-US" sz="1050" dirty="0"/>
-          </a:p>
-          <a:p>
+              <a:t>Guo, T. et al. (2024) 'Large language model based multi-agents: a survey of progress and challenges', in </a:t>
+            </a:r>
             <a:pPr indent="0" marL="0">
               <a:spcAft>
-                <a:spcPts val="400"/>
+                <a:spcPts val="500"/>
               </a:spcAft>
               <a:buNone/>
             </a:pPr>
             <a:r>
-              <a:rPr lang="en-US" sz="1050" dirty="0">
+              <a:rPr lang="en-US" sz="1000" i="1" dirty="0">
                 <a:solidFill>
                   <a:srgbClr val="CBD5E1"/>
                 </a:solidFill>
               </a:rPr>
-              <a:t>Hayes-Roth, B. (1985) 'A blackboard architecture for control', Artificial Intelligence, 26(3), pp. 251–321.</a:t>
-            </a:r>
-            <a:endParaRPr lang="en-US" sz="1050" dirty="0"/>
-          </a:p>
-          <a:p>
+              <a:t>Proceedings of IJCAI-24</a:t>
+            </a:r>
             <a:pPr indent="0" marL="0">
               <a:spcAft>
-                <a:spcPts val="400"/>
+                <a:spcPts val="300"/>
               </a:spcAft>
               <a:buNone/>
             </a:pPr>
             <a:r>
-              <a:rPr lang="en-US" sz="1050" dirty="0">
+              <a:rPr lang="en-US" sz="1000" dirty="0">
                 <a:solidFill>
                   <a:srgbClr val="CBD5E1"/>
                 </a:solidFill>
               </a:rPr>
-              <a:t>Ji, Z. et al. (2023) 'Survey of hallucination in natural language generation', ACM Computing Surveys, 55(12), pp. 1–38.</a:t>
-            </a:r>
-            <a:endParaRPr lang="en-US" sz="1050" dirty="0"/>
+              <a:t>, pp. 8048–8057. Available at: https://doi.org/10.24963/ijcai.2024/890 (Accessed: 11 October 2026).</a:t>
+            </a:r>
+            <a:endParaRPr lang="en-US" sz="1000" dirty="0"/>
           </a:p>
           <a:p>
             <a:pPr indent="0" marL="0">
               <a:spcAft>
-                <a:spcPts val="400"/>
+                <a:spcPts val="500"/>
               </a:spcAft>
               <a:buNone/>
             </a:pPr>
             <a:r>
-              <a:rPr lang="en-US" sz="1050" dirty="0">
+              <a:rPr lang="en-US" sz="1000" dirty="0">
                 <a:solidFill>
                   <a:srgbClr val="CBD5E1"/>
                 </a:solidFill>
               </a:rPr>
-              <a:t>Kambhampati, S. et al. (2024) 'Position: LLMs can't plan, but can help planning in LLM-Modulo frameworks', ICML 2024. PMLR 235.</a:t>
-            </a:r>
-            <a:endParaRPr lang="en-US" sz="1050" dirty="0"/>
-          </a:p>
-          <a:p>
+              <a:t>Hayes-Roth, B. (1985) 'A blackboard architecture for control', </a:t>
+            </a:r>
             <a:pPr indent="0" marL="0">
               <a:spcAft>
-                <a:spcPts val="400"/>
+                <a:spcPts val="500"/>
               </a:spcAft>
               <a:buNone/>
             </a:pPr>
             <a:r>
-              <a:rPr lang="en-US" sz="1050" dirty="0">
+              <a:rPr lang="en-US" sz="1000" i="1" dirty="0">
                 <a:solidFill>
                   <a:srgbClr val="CBD5E1"/>
                 </a:solidFill>
               </a:rPr>
-              <a:t>Salemi, A. et al. (2025) 'LLM-based multi-agent blackboard system for information discovery in data science', arXiv:2510.01285.</a:t>
-            </a:r>
-            <a:endParaRPr lang="en-US" sz="1050" dirty="0"/>
-          </a:p>
-          <a:p>
+              <a:t>Artificial Intelligence</a:t>
+            </a:r>
             <a:pPr indent="0" marL="0">
               <a:spcAft>
-                <a:spcPts val="400"/>
+                <a:spcPts val="300"/>
               </a:spcAft>
               <a:buNone/>
             </a:pPr>
             <a:r>
-              <a:rPr lang="en-US" sz="1050" dirty="0">
+              <a:rPr lang="en-US" sz="1000" dirty="0">
                 <a:solidFill>
                   <a:srgbClr val="CBD5E1"/>
                 </a:solidFill>
               </a:rPr>
-              <a:t>Shinn, N. et al. (2023) 'Reflexion: language agents with verbal reinforcement learning', NeurIPS 36.</a:t>
-            </a:r>
-            <a:endParaRPr lang="en-US" sz="1050" dirty="0"/>
+              <a:t>, 26(3), pp. 251–321. Available at: https://doi.org/10.1016/0004-3702(85)90063-3 (Accessed: 11 October 2026).</a:t>
+            </a:r>
+            <a:endParaRPr lang="en-US" sz="1000" dirty="0"/>
           </a:p>
           <a:p>
             <a:pPr indent="0" marL="0">
               <a:spcAft>
-                <a:spcPts val="400"/>
+                <a:spcPts val="500"/>
               </a:spcAft>
               <a:buNone/>
             </a:pPr>
             <a:r>
-              <a:rPr lang="en-US" sz="1050" dirty="0">
+              <a:rPr lang="en-US" sz="1000" dirty="0">
                 <a:solidFill>
                   <a:srgbClr val="CBD5E1"/>
                 </a:solidFill>
               </a:rPr>
-              <a:t>Wooldridge, M. (2009) An Introduction to MultiAgent Systems. 2nd edn. Chichester: Wiley.</a:t>
-            </a:r>
-            <a:endParaRPr lang="en-US" sz="1050" dirty="0"/>
-          </a:p>
-          <a:p>
+              <a:t>Ji, Z. et al. (2023) 'Survey of hallucination in natural language generation', </a:t>
+            </a:r>
             <a:pPr indent="0" marL="0">
               <a:spcAft>
-                <a:spcPts val="400"/>
+                <a:spcPts val="500"/>
               </a:spcAft>
               <a:buNone/>
             </a:pPr>
             <a:r>
-              <a:rPr lang="en-US" sz="1050" dirty="0">
+              <a:rPr lang="en-US" sz="1000" i="1" dirty="0">
                 <a:solidFill>
                   <a:srgbClr val="CBD5E1"/>
                 </a:solidFill>
               </a:rPr>
-              <a:t>Wooldridge, M., Jennings, N.R. and Kinny, D. (2000) 'The Gaia methodology for agent-oriented analysis and design', AAMAS, 3(3), pp. 285–312.</a:t>
-            </a:r>
-            <a:endParaRPr lang="en-US" sz="1050" dirty="0"/>
-          </a:p>
-          <a:p>
+              <a:t>ACM Computing Surveys</a:t>
+            </a:r>
             <a:pPr indent="0" marL="0">
               <a:spcAft>
-                <a:spcPts val="400"/>
+                <a:spcPts val="300"/>
               </a:spcAft>
               <a:buNone/>
             </a:pPr>
             <a:r>
-              <a:rPr lang="en-US" sz="1050" dirty="0">
+              <a:rPr lang="en-US" sz="1000" dirty="0">
                 <a:solidFill>
                   <a:srgbClr val="CBD5E1"/>
                 </a:solidFill>
               </a:rPr>
-              <a:t>Yao, S. et al. (2023) 'ReAct: synergizing reasoning and acting in language models', ICLR 2023.</a:t>
-            </a:r>
-            <a:endParaRPr lang="en-US" sz="1050" dirty="0"/>
+              <a:t>, 55(12), pp. 1–38. Available at: https://doi.org/10.1145/3571730 (Accessed: 11 October 2026).</a:t>
+            </a:r>
+            <a:endParaRPr lang="en-US" sz="1000" dirty="0"/>
+          </a:p>
+          <a:p>
+            <a:pPr indent="0" marL="0">
+              <a:spcAft>
+                <a:spcPts val="500"/>
+              </a:spcAft>
+              <a:buNone/>
+            </a:pPr>
+            <a:r>
+              <a:rPr lang="en-US" sz="1000" dirty="0">
+                <a:solidFill>
+                  <a:srgbClr val="CBD5E1"/>
+                </a:solidFill>
+              </a:rPr>
+              <a:t>Kambhampati, S. et al. (2024) 'Position: LLMs can't plan, but can help planning in LLM-Modulo frameworks', in </a:t>
+            </a:r>
+            <a:pPr indent="0" marL="0">
+              <a:spcAft>
+                <a:spcPts val="500"/>
+              </a:spcAft>
+              <a:buNone/>
+            </a:pPr>
+            <a:r>
+              <a:rPr lang="en-US" sz="1000" i="1" dirty="0">
+                <a:solidFill>
+                  <a:srgbClr val="CBD5E1"/>
+                </a:solidFill>
+              </a:rPr>
+              <a:t>Proceedings of ICML 2024</a:t>
+            </a:r>
+            <a:pPr indent="0" marL="0">
+              <a:spcAft>
+                <a:spcPts val="300"/>
+              </a:spcAft>
+              <a:buNone/>
+            </a:pPr>
+            <a:r>
+              <a:rPr lang="en-US" sz="1000" dirty="0">
+                <a:solidFill>
+                  <a:srgbClr val="CBD5E1"/>
+                </a:solidFill>
+              </a:rPr>
+              <a:t>. Vienna: PMLR 235. Available at: https://arxiv.org/abs/2402.01817 (Accessed: 11 October 2026).</a:t>
+            </a:r>
+            <a:endParaRPr lang="en-US" sz="1000" dirty="0"/>
+          </a:p>
+          <a:p>
+            <a:pPr indent="0" marL="0">
+              <a:spcAft>
+                <a:spcPts val="500"/>
+              </a:spcAft>
+              <a:buNone/>
+            </a:pPr>
+            <a:r>
+              <a:rPr lang="en-US" sz="1000" dirty="0">
+                <a:solidFill>
+                  <a:srgbClr val="CBD5E1"/>
+                </a:solidFill>
+              </a:rPr>
+              <a:t>Salemi, A. et al. (2025) 'LLM-based multi-agent blackboard system for information discovery in data science', </a:t>
+            </a:r>
+            <a:pPr indent="0" marL="0">
+              <a:spcAft>
+                <a:spcPts val="500"/>
+              </a:spcAft>
+              <a:buNone/>
+            </a:pPr>
+            <a:r>
+              <a:rPr lang="en-US" sz="1000" i="1" dirty="0">
+                <a:solidFill>
+                  <a:srgbClr val="CBD5E1"/>
+                </a:solidFill>
+              </a:rPr>
+              <a:t>arXiv preprint</a:t>
+            </a:r>
+            <a:pPr indent="0" marL="0">
+              <a:spcAft>
+                <a:spcPts val="300"/>
+              </a:spcAft>
+              <a:buNone/>
+            </a:pPr>
+            <a:r>
+              <a:rPr lang="en-US" sz="1000" dirty="0">
+                <a:solidFill>
+                  <a:srgbClr val="CBD5E1"/>
+                </a:solidFill>
+              </a:rPr>
+              <a:t> arXiv:2510.01285. Available at: https://arxiv.org/abs/2510.01285 (Accessed: 11 October 2026).</a:t>
+            </a:r>
+            <a:endParaRPr lang="en-US" sz="1000" dirty="0"/>
+          </a:p>
+          <a:p>
+            <a:pPr indent="0" marL="0">
+              <a:spcAft>
+                <a:spcPts val="500"/>
+              </a:spcAft>
+              <a:buNone/>
+            </a:pPr>
+            <a:r>
+              <a:rPr lang="en-US" sz="1000" dirty="0">
+                <a:solidFill>
+                  <a:srgbClr val="CBD5E1"/>
+                </a:solidFill>
+              </a:rPr>
+              <a:t>Shinn, N. et al. (2023) 'Reflexion: language agents with verbal reinforcement learning', in </a:t>
+            </a:r>
+            <a:pPr indent="0" marL="0">
+              <a:spcAft>
+                <a:spcPts val="500"/>
+              </a:spcAft>
+              <a:buNone/>
+            </a:pPr>
+            <a:r>
+              <a:rPr lang="en-US" sz="1000" i="1" dirty="0">
+                <a:solidFill>
+                  <a:srgbClr val="CBD5E1"/>
+                </a:solidFill>
+              </a:rPr>
+              <a:t>Advances in Neural Information Processing Systems 36</a:t>
+            </a:r>
+            <a:pPr indent="0" marL="0">
+              <a:spcAft>
+                <a:spcPts val="300"/>
+              </a:spcAft>
+              <a:buNone/>
+            </a:pPr>
+            <a:r>
+              <a:rPr lang="en-US" sz="1000" dirty="0">
+                <a:solidFill>
+                  <a:srgbClr val="CBD5E1"/>
+                </a:solidFill>
+              </a:rPr>
+              <a:t>. Available at: https://arxiv.org/abs/2303.11366 (Accessed: 11 October 2026).</a:t>
+            </a:r>
+            <a:endParaRPr lang="en-US" sz="1000" dirty="0"/>
+          </a:p>
+          <a:p>
+            <a:pPr indent="0" marL="0">
+              <a:spcAft>
+                <a:spcPts val="500"/>
+              </a:spcAft>
+              <a:buNone/>
+            </a:pPr>
+            <a:r>
+              <a:rPr lang="en-US" sz="1000" dirty="0">
+                <a:solidFill>
+                  <a:srgbClr val="CBD5E1"/>
+                </a:solidFill>
+              </a:rPr>
+              <a:t>Wooldridge, M. (2009) </a:t>
+            </a:r>
+            <a:pPr indent="0" marL="0">
+              <a:spcAft>
+                <a:spcPts val="500"/>
+              </a:spcAft>
+              <a:buNone/>
+            </a:pPr>
+            <a:r>
+              <a:rPr lang="en-US" sz="1000" i="1" dirty="0">
+                <a:solidFill>
+                  <a:srgbClr val="CBD5E1"/>
+                </a:solidFill>
+              </a:rPr>
+              <a:t>An Introduction to MultiAgent Systems</a:t>
+            </a:r>
+            <a:pPr indent="0" marL="0">
+              <a:spcAft>
+                <a:spcPts val="300"/>
+              </a:spcAft>
+              <a:buNone/>
+            </a:pPr>
+            <a:r>
+              <a:rPr lang="en-US" sz="1000" dirty="0">
+                <a:solidFill>
+                  <a:srgbClr val="CBD5E1"/>
+                </a:solidFill>
+              </a:rPr>
+              <a:t>. 2nd edn. Chichester: John Wiley &amp; Sons.</a:t>
+            </a:r>
+            <a:endParaRPr lang="en-US" sz="1000" dirty="0"/>
+          </a:p>
+          <a:p>
+            <a:pPr indent="0" marL="0">
+              <a:spcAft>
+                <a:spcPts val="500"/>
+              </a:spcAft>
+              <a:buNone/>
+            </a:pPr>
+            <a:r>
+              <a:rPr lang="en-US" sz="1000" dirty="0">
+                <a:solidFill>
+                  <a:srgbClr val="CBD5E1"/>
+                </a:solidFill>
+              </a:rPr>
+              <a:t>Wooldridge, M., Jennings, N.R. and Kinny, D. (2000) 'The Gaia methodology for agent-oriented analysis and design', </a:t>
+            </a:r>
+            <a:pPr indent="0" marL="0">
+              <a:spcAft>
+                <a:spcPts val="500"/>
+              </a:spcAft>
+              <a:buNone/>
+            </a:pPr>
+            <a:r>
+              <a:rPr lang="en-US" sz="1000" i="1" dirty="0">
+                <a:solidFill>
+                  <a:srgbClr val="CBD5E1"/>
+                </a:solidFill>
+              </a:rPr>
+              <a:t>Autonomous Agents and Multi-Agent Systems</a:t>
+            </a:r>
+            <a:pPr indent="0" marL="0">
+              <a:spcAft>
+                <a:spcPts val="300"/>
+              </a:spcAft>
+              <a:buNone/>
+            </a:pPr>
+            <a:r>
+              <a:rPr lang="en-US" sz="1000" dirty="0">
+                <a:solidFill>
+                  <a:srgbClr val="CBD5E1"/>
+                </a:solidFill>
+              </a:rPr>
+              <a:t>, 3(3), pp. 285–312. Available at: https://doi.org/10.1023/A:1010071910869 (Accessed: 11 October 2026).</a:t>
+            </a:r>
+            <a:endParaRPr lang="en-US" sz="1000" dirty="0"/>
+          </a:p>
+          <a:p>
+            <a:pPr indent="0" marL="0">
+              <a:spcAft>
+                <a:spcPts val="500"/>
+              </a:spcAft>
+              <a:buNone/>
+            </a:pPr>
+            <a:r>
+              <a:rPr lang="en-US" sz="1000" dirty="0">
+                <a:solidFill>
+                  <a:srgbClr val="CBD5E1"/>
+                </a:solidFill>
+              </a:rPr>
+              <a:t>Yao, S. et al. (2023) 'ReAct: synergizing reasoning and acting in language models', in </a:t>
+            </a:r>
+            <a:pPr indent="0" marL="0">
+              <a:spcAft>
+                <a:spcPts val="500"/>
+              </a:spcAft>
+              <a:buNone/>
+            </a:pPr>
+            <a:r>
+              <a:rPr lang="en-US" sz="1000" i="1" dirty="0">
+                <a:solidFill>
+                  <a:srgbClr val="CBD5E1"/>
+                </a:solidFill>
+              </a:rPr>
+              <a:t>Proceedings of ICLR 2023</a:t>
+            </a:r>
+            <a:pPr indent="0" marL="0">
+              <a:spcAft>
+                <a:spcPts val="300"/>
+              </a:spcAft>
+              <a:buNone/>
+            </a:pPr>
+            <a:r>
+              <a:rPr lang="en-US" sz="1000" dirty="0">
+                <a:solidFill>
+                  <a:srgbClr val="CBD5E1"/>
+                </a:solidFill>
+              </a:rPr>
+              <a:t>. Available at: https://arxiv.org/abs/2210.03629 (Accessed: 11 October 2026).</a:t>
+            </a:r>
+            <a:endParaRPr lang="en-US" sz="1000" dirty="0"/>
           </a:p>
         </p:txBody>
       </p:sp>
@@ -3993,7 +4245,7 @@
         </p:nvSpPr>
         <p:spPr>
           <a:xfrm>
-            <a:off x="6309360" y="5532120"/>
+            <a:off x="6309360" y="6089904"/>
             <a:ext cx="5349240" cy="274320"/>
           </a:xfrm>
           <a:prstGeom prst="rect">
@@ -4015,7 +4267,7 @@
                   <a:srgbClr val="94A3B8"/>
                 </a:solidFill>
               </a:rPr>
-              <a:t>Full Harvard reference list with DOIs and access dates: README §13</a:t>
+              <a:t>Full reference list (all sources used in the code and README): README §13</a:t>
             </a:r>
             <a:endParaRPr lang="en-US" sz="1000" dirty="0"/>
           </a:p>

</xml_diff>